<commit_message>
Owner edit: Kit 4 slide 3 numbers get on-slide context
Both stat cards now explain their number where it's read: 0.79 framed as
feedback's average effect size (roughly double a typical intervention,
Hattie & Timperley 2007) and ≤15% framed as the share of AI-using teachers
who used AI for writing assessments (RAND 2025). Card text meets the 16pt
floor; claims unchanged from RESEARCH_LOG.

Co-Authored-By: Claude Fable 5 <noreply@anthropic.com>
Claude-Session: https://claude.ai/code/session_01EsE79TDyHfL767rcqG6D4Q
</commit_message>
<xml_diff>
--- a/kits/kit04/Kit04_PresentationDeck.pptx
+++ b/kits/kit04/Kit04_PresentationDeck.pptx
@@ -13848,8 +13848,8 @@
         </p:nvSpPr>
         <p:spPr>
           <a:xfrm>
-            <a:off x="640080" y="1920240"/>
-            <a:ext cx="5257800" cy="1097280"/>
+            <a:off x="640080" y="1783080"/>
+            <a:ext cx="5257800" cy="320040"/>
           </a:xfrm>
           <a:prstGeom prst="rect">
             <a:avLst/>
@@ -13865,7 +13865,7 @@
               <a:buNone/>
             </a:pPr>
             <a:r>
-              <a:rPr lang="en-US" sz="5800" b="1" dirty="0">
+              <a:rPr lang="en-US" sz="1300" b="1" spc="200" kern="0" dirty="0">
                 <a:solidFill>
                   <a:srgbClr val="2A9D8F"/>
                 </a:solidFill>
@@ -13873,22 +13873,61 @@
                 <a:ea typeface="Inter" pitchFamily="34" charset="-122"/>
                 <a:cs typeface="Inter" pitchFamily="34" charset="-120"/>
               </a:rPr>
+              <a:t>THE POWER OF FEEDBACK</a:t>
+            </a:r>
+            <a:endParaRPr lang="en-US" sz="1300" dirty="0"/>
+          </a:p>
+        </p:txBody>
+      </p:sp>
+      <p:sp>
+        <p:nvSpPr>
+          <p:cNvPr id="9" name="Text 6"/>
+          <p:cNvSpPr/>
+          <p:nvPr/>
+        </p:nvSpPr>
+        <p:spPr>
+          <a:xfrm>
+            <a:off x="640080" y="2103120"/>
+            <a:ext cx="5257800" cy="960120"/>
+          </a:xfrm>
+          <a:prstGeom prst="rect">
+            <a:avLst/>
+          </a:prstGeom>
+          <a:noFill/>
+          <a:ln/>
+        </p:spPr>
+        <p:txBody>
+          <a:bodyPr wrap="square" lIns="0" tIns="0" rIns="0" bIns="0" rtlCol="0" anchor="ctr"/>
+          <a:lstStyle/>
+          <a:p>
+            <a:pPr algn="ctr" indent="0" marL="0">
+              <a:buNone/>
+            </a:pPr>
+            <a:r>
+              <a:rPr lang="en-US" sz="5200" b="1" dirty="0">
+                <a:solidFill>
+                  <a:srgbClr val="2A9D8F"/>
+                </a:solidFill>
+                <a:latin typeface="Inter" pitchFamily="34" charset="0"/>
+                <a:ea typeface="Inter" pitchFamily="34" charset="-122"/>
+                <a:cs typeface="Inter" pitchFamily="34" charset="-120"/>
+              </a:rPr>
               <a:t>0.79</a:t>
             </a:r>
-            <a:endParaRPr lang="en-US" sz="5800" dirty="0"/>
-          </a:p>
-        </p:txBody>
-      </p:sp>
-      <p:sp>
-        <p:nvSpPr>
-          <p:cNvPr id="9" name="Text 6"/>
+            <a:endParaRPr lang="en-US" sz="5200" dirty="0"/>
+          </a:p>
+        </p:txBody>
+      </p:sp>
+      <p:sp>
+        <p:nvSpPr>
+          <p:cNvPr id="10" name="Text 7"/>
           <p:cNvSpPr/>
           <p:nvPr/>
         </p:nvSpPr>
         <p:spPr>
           <a:xfrm>
             <a:off x="914400" y="3108960"/>
-            <a:ext cx="4709160" cy="1645920"/>
+            <a:ext cx="4709160" cy="1737360"/>
           </a:xfrm>
           <a:prstGeom prst="rect">
             <a:avLst/>
@@ -13904,7 +13943,7 @@
               <a:buNone/>
             </a:pPr>
             <a:r>
-              <a:rPr lang="en-US" sz="1550" dirty="0">
+              <a:rPr lang="en-US" sz="1600" dirty="0">
                 <a:solidFill>
                   <a:srgbClr val="1B1F24"/>
                 </a:solidFill>
@@ -13912,49 +13951,15 @@
                 <a:ea typeface="Inter" pitchFamily="34" charset="-122"/>
                 <a:cs typeface="Inter" pitchFamily="34" charset="-120"/>
               </a:rPr>
-              <a:t>average effect size of feedback,</a:t>
-            </a:r>
-            <a:endParaRPr lang="en-US" sz="1550" dirty="0"/>
-          </a:p>
-          <a:p>
-            <a:pPr algn="ctr" indent="0" marL="0">
-              <a:buNone/>
-            </a:pPr>
-            <a:r>
-              <a:rPr lang="en-US" sz="1550" dirty="0">
-                <a:solidFill>
-                  <a:srgbClr val="1B1F24"/>
-                </a:solidFill>
-                <a:latin typeface="Inter" pitchFamily="34" charset="0"/>
-                <a:ea typeface="Inter" pitchFamily="34" charset="-122"/>
-                <a:cs typeface="Inter" pitchFamily="34" charset="-120"/>
-              </a:rPr>
-              <a:t>among the most powerful influences</a:t>
-            </a:r>
-            <a:endParaRPr lang="en-US" sz="1550" dirty="0"/>
-          </a:p>
-          <a:p>
-            <a:pPr algn="ctr" indent="0" marL="0">
-              <a:buNone/>
-            </a:pPr>
-            <a:r>
-              <a:rPr lang="en-US" sz="1550" dirty="0">
-                <a:solidFill>
-                  <a:srgbClr val="1B1F24"/>
-                </a:solidFill>
-                <a:latin typeface="Inter" pitchFamily="34" charset="0"/>
-                <a:ea typeface="Inter" pitchFamily="34" charset="-122"/>
-                <a:cs typeface="Inter" pitchFamily="34" charset="-120"/>
-              </a:rPr>
-              <a:t>on achievement (Hattie &amp; Timperley)</a:t>
-            </a:r>
-            <a:endParaRPr lang="en-US" sz="1550" dirty="0"/>
-          </a:p>
-        </p:txBody>
-      </p:sp>
-      <p:sp>
-        <p:nvSpPr>
-          <p:cNvPr id="10" name="Shape 7"/>
+              <a:t>Feedback’s average “effect size” on student achievement: roughly double the impact of the typical educational intervention. (Hattie &amp; Timperley, 2007)</a:t>
+            </a:r>
+            <a:endParaRPr lang="en-US" sz="1600" dirty="0"/>
+          </a:p>
+        </p:txBody>
+      </p:sp>
+      <p:sp>
+        <p:nvSpPr>
+          <p:cNvPr id="11" name="Shape 8"/>
           <p:cNvSpPr/>
           <p:nvPr/>
         </p:nvSpPr>
@@ -13981,14 +13986,14 @@
       </p:sp>
       <p:sp>
         <p:nvSpPr>
-          <p:cNvPr id="11" name="Text 8"/>
-          <p:cNvSpPr/>
-          <p:nvPr/>
-        </p:nvSpPr>
-        <p:spPr>
-          <a:xfrm>
-            <a:off x="6263640" y="1920240"/>
-            <a:ext cx="5257800" cy="1097280"/>
+          <p:cNvPr id="12" name="Text 9"/>
+          <p:cNvSpPr/>
+          <p:nvPr/>
+        </p:nvSpPr>
+        <p:spPr>
+          <a:xfrm>
+            <a:off x="6263640" y="1783080"/>
+            <a:ext cx="5257800" cy="320040"/>
           </a:xfrm>
           <a:prstGeom prst="rect">
             <a:avLst/>
@@ -14004,7 +14009,7 @@
               <a:buNone/>
             </a:pPr>
             <a:r>
-              <a:rPr lang="en-US" sz="5800" b="1" dirty="0">
+              <a:rPr lang="en-US" sz="1300" b="1" spc="200" kern="0" dirty="0">
                 <a:solidFill>
                   <a:srgbClr val="5B6B7A"/>
                 </a:solidFill>
@@ -14012,22 +14017,61 @@
                 <a:ea typeface="Inter" pitchFamily="34" charset="-122"/>
                 <a:cs typeface="Inter" pitchFamily="34" charset="-120"/>
               </a:rPr>
+              <a:t>HOW MANY TEACHERS TAP IT WITH AI</a:t>
+            </a:r>
+            <a:endParaRPr lang="en-US" sz="1300" dirty="0"/>
+          </a:p>
+        </p:txBody>
+      </p:sp>
+      <p:sp>
+        <p:nvSpPr>
+          <p:cNvPr id="13" name="Text 10"/>
+          <p:cNvSpPr/>
+          <p:nvPr/>
+        </p:nvSpPr>
+        <p:spPr>
+          <a:xfrm>
+            <a:off x="6263640" y="2103120"/>
+            <a:ext cx="5257800" cy="960120"/>
+          </a:xfrm>
+          <a:prstGeom prst="rect">
+            <a:avLst/>
+          </a:prstGeom>
+          <a:noFill/>
+          <a:ln/>
+        </p:spPr>
+        <p:txBody>
+          <a:bodyPr wrap="square" lIns="0" tIns="0" rIns="0" bIns="0" rtlCol="0" anchor="ctr"/>
+          <a:lstStyle/>
+          <a:p>
+            <a:pPr algn="ctr" indent="0" marL="0">
+              <a:buNone/>
+            </a:pPr>
+            <a:r>
+              <a:rPr lang="en-US" sz="5200" b="1" dirty="0">
+                <a:solidFill>
+                  <a:srgbClr val="5B6B7A"/>
+                </a:solidFill>
+                <a:latin typeface="Inter" pitchFamily="34" charset="0"/>
+                <a:ea typeface="Inter" pitchFamily="34" charset="-122"/>
+                <a:cs typeface="Inter" pitchFamily="34" charset="-120"/>
+              </a:rPr>
               <a:t>≤15%</a:t>
             </a:r>
-            <a:endParaRPr lang="en-US" sz="5800" dirty="0"/>
-          </a:p>
-        </p:txBody>
-      </p:sp>
-      <p:sp>
-        <p:nvSpPr>
-          <p:cNvPr id="12" name="Text 9"/>
+            <a:endParaRPr lang="en-US" sz="5200" dirty="0"/>
+          </a:p>
+        </p:txBody>
+      </p:sp>
+      <p:sp>
+        <p:nvSpPr>
+          <p:cNvPr id="14" name="Text 11"/>
           <p:cNvSpPr/>
           <p:nvPr/>
         </p:nvSpPr>
         <p:spPr>
           <a:xfrm>
             <a:off x="6537960" y="3108960"/>
-            <a:ext cx="4709160" cy="1645920"/>
+            <a:ext cx="4709160" cy="1737360"/>
           </a:xfrm>
           <a:prstGeom prst="rect">
             <a:avLst/>
@@ -14043,7 +14087,7 @@
               <a:buNone/>
             </a:pPr>
             <a:r>
-              <a:rPr lang="en-US" sz="1550" dirty="0">
+              <a:rPr lang="en-US" sz="1600" dirty="0">
                 <a:solidFill>
                   <a:srgbClr val="1B1F24"/>
                 </a:solidFill>
@@ -14051,49 +14095,15 @@
                 <a:ea typeface="Inter" pitchFamily="34" charset="-122"/>
                 <a:cs typeface="Inter" pitchFamily="34" charset="-120"/>
               </a:rPr>
-              <a:t>of AI-using teachers used AI</a:t>
-            </a:r>
-            <a:endParaRPr lang="en-US" sz="1550" dirty="0"/>
-          </a:p>
-          <a:p>
-            <a:pPr algn="ctr" indent="0" marL="0">
-              <a:buNone/>
-            </a:pPr>
-            <a:r>
-              <a:rPr lang="en-US" sz="1550" dirty="0">
-                <a:solidFill>
-                  <a:srgbClr val="1B1F24"/>
-                </a:solidFill>
-                <a:latin typeface="Inter" pitchFamily="34" charset="0"/>
-                <a:ea typeface="Inter" pitchFamily="34" charset="-122"/>
-                <a:cs typeface="Inter" pitchFamily="34" charset="-120"/>
-              </a:rPr>
-              <a:t>for writing assessments in 2023–24</a:t>
-            </a:r>
-            <a:endParaRPr lang="en-US" sz="1550" dirty="0"/>
-          </a:p>
-          <a:p>
-            <a:pPr algn="ctr" indent="0" marL="0">
-              <a:buNone/>
-            </a:pPr>
-            <a:r>
-              <a:rPr lang="en-US" sz="1550" dirty="0">
-                <a:solidFill>
-                  <a:srgbClr val="1B1F24"/>
-                </a:solidFill>
-                <a:latin typeface="Inter" pitchFamily="34" charset="0"/>
-                <a:ea typeface="Inter" pitchFamily="34" charset="-122"/>
-                <a:cs typeface="Inter" pitchFamily="34" charset="-120"/>
-              </a:rPr>
-              <a:t>(RAND, 2025)</a:t>
-            </a:r>
-            <a:endParaRPr lang="en-US" sz="1550" dirty="0"/>
-          </a:p>
-        </p:txBody>
-      </p:sp>
-      <p:sp>
-        <p:nvSpPr>
-          <p:cNvPr id="13" name="Text 10"/>
+              <a:t>Of teachers who already used AI in 2023–24, 15% or fewer used it for writing assessments: the least-tapped use, sitting under the highest-leverage work. (RAND, 2025)</a:t>
+            </a:r>
+            <a:endParaRPr lang="en-US" sz="1600" dirty="0"/>
+          </a:p>
+        </p:txBody>
+      </p:sp>
+      <p:sp>
+        <p:nvSpPr>
+          <p:cNvPr id="15" name="Text 12"/>
           <p:cNvSpPr/>
           <p:nvPr/>
         </p:nvSpPr>

</xml_diff>

<commit_message>
Owner edit: Kit 4 slide 12 numbers get on-slide context
Same treatment as slide 3: labeled stat cards with plain-language framing.
97% framed as teachers judging AI-drafted quiz questions on-topic and
3.6/4 as their usefulness score with vetting integral (Elkins et al., 2023).
Card text at the 16pt floor; claims unchanged from RESEARCH_LOG.

Co-Authored-By: Claude Fable 5 <noreply@anthropic.com>
Claude-Session: https://claude.ai/code/session_01EsE79TDyHfL767rcqG6D4Q
</commit_message>
<xml_diff>
--- a/kits/kit04/Kit04_PresentationDeck.pptx
+++ b/kits/kit04/Kit04_PresentationDeck.pptx
@@ -4736,8 +4736,8 @@
         </p:nvSpPr>
         <p:spPr>
           <a:xfrm>
-            <a:off x="640080" y="1874520"/>
-            <a:ext cx="5257800" cy="1005840"/>
+            <a:off x="640080" y="1737360"/>
+            <a:ext cx="5257800" cy="292608"/>
           </a:xfrm>
           <a:prstGeom prst="rect">
             <a:avLst/>
@@ -4753,7 +4753,7 @@
               <a:buNone/>
             </a:pPr>
             <a:r>
-              <a:rPr lang="en-US" sz="5400" b="1" dirty="0">
+              <a:rPr lang="en-US" sz="1300" b="1" spc="200" kern="0" dirty="0">
                 <a:solidFill>
                   <a:srgbClr val="2A9D8F"/>
                 </a:solidFill>
@@ -4761,22 +4761,61 @@
                 <a:ea typeface="Inter" pitchFamily="34" charset="-122"/>
                 <a:cs typeface="Inter" pitchFamily="34" charset="-120"/>
               </a:rPr>
+              <a:t>HOW OFTEN DRAFTS ARE ON-TOPIC</a:t>
+            </a:r>
+            <a:endParaRPr lang="en-US" sz="1300" dirty="0"/>
+          </a:p>
+        </p:txBody>
+      </p:sp>
+      <p:sp>
+        <p:nvSpPr>
+          <p:cNvPr id="9" name="Text 6"/>
+          <p:cNvSpPr/>
+          <p:nvPr/>
+        </p:nvSpPr>
+        <p:spPr>
+          <a:xfrm>
+            <a:off x="640080" y="2029968"/>
+            <a:ext cx="5257800" cy="868680"/>
+          </a:xfrm>
+          <a:prstGeom prst="rect">
+            <a:avLst/>
+          </a:prstGeom>
+          <a:noFill/>
+          <a:ln/>
+        </p:spPr>
+        <p:txBody>
+          <a:bodyPr wrap="square" lIns="0" tIns="0" rIns="0" bIns="0" rtlCol="0" anchor="ctr"/>
+          <a:lstStyle/>
+          <a:p>
+            <a:pPr algn="ctr" indent="0" marL="0">
+              <a:buNone/>
+            </a:pPr>
+            <a:r>
+              <a:rPr lang="en-US" sz="4800" b="1" dirty="0">
+                <a:solidFill>
+                  <a:srgbClr val="2A9D8F"/>
+                </a:solidFill>
+                <a:latin typeface="Inter" pitchFamily="34" charset="0"/>
+                <a:ea typeface="Inter" pitchFamily="34" charset="-122"/>
+                <a:cs typeface="Inter" pitchFamily="34" charset="-120"/>
+              </a:rPr>
               <a:t>97%</a:t>
             </a:r>
-            <a:endParaRPr lang="en-US" sz="5400" dirty="0"/>
-          </a:p>
-        </p:txBody>
-      </p:sp>
-      <p:sp>
-        <p:nvSpPr>
-          <p:cNvPr id="9" name="Text 6"/>
-          <p:cNvSpPr/>
-          <p:nvPr/>
-        </p:nvSpPr>
-        <p:spPr>
-          <a:xfrm>
-            <a:off x="914400" y="2926080"/>
-            <a:ext cx="4709160" cy="1371600"/>
+            <a:endParaRPr lang="en-US" sz="4800" dirty="0"/>
+          </a:p>
+        </p:txBody>
+      </p:sp>
+      <p:sp>
+        <p:nvSpPr>
+          <p:cNvPr id="10" name="Text 7"/>
+          <p:cNvSpPr/>
+          <p:nvPr/>
+        </p:nvSpPr>
+        <p:spPr>
+          <a:xfrm>
+            <a:off x="914400" y="2971800"/>
+            <a:ext cx="4709160" cy="1463040"/>
           </a:xfrm>
           <a:prstGeom prst="rect">
             <a:avLst/>
@@ -4792,7 +4831,7 @@
               <a:buNone/>
             </a:pPr>
             <a:r>
-              <a:rPr lang="en-US" sz="1550" dirty="0">
+              <a:rPr lang="en-US" sz="1600" dirty="0">
                 <a:solidFill>
                   <a:srgbClr val="1B1F24"/>
                 </a:solidFill>
@@ -4800,49 +4839,15 @@
                 <a:ea typeface="Inter" pitchFamily="34" charset="-122"/>
                 <a:cs typeface="Inter" pitchFamily="34" charset="-120"/>
               </a:rPr>
-              <a:t>of LLM-drafted questions rated</a:t>
-            </a:r>
-            <a:endParaRPr lang="en-US" sz="1550" dirty="0"/>
-          </a:p>
-          <a:p>
-            <a:pPr algn="ctr" indent="0" marL="0">
-              <a:buNone/>
-            </a:pPr>
-            <a:r>
-              <a:rPr lang="en-US" sz="1550" dirty="0">
-                <a:solidFill>
-                  <a:srgbClr val="1B1F24"/>
-                </a:solidFill>
-                <a:latin typeface="Inter" pitchFamily="34" charset="0"/>
-                <a:ea typeface="Inter" pitchFamily="34" charset="-122"/>
-                <a:cs typeface="Inter" pitchFamily="34" charset="-120"/>
-              </a:rPr>
-              <a:t>topic-relevant by teachers</a:t>
-            </a:r>
-            <a:endParaRPr lang="en-US" sz="1550" dirty="0"/>
-          </a:p>
-          <a:p>
-            <a:pPr algn="ctr" indent="0" marL="0">
-              <a:buNone/>
-            </a:pPr>
-            <a:r>
-              <a:rPr lang="en-US" sz="1550" dirty="0">
-                <a:solidFill>
-                  <a:srgbClr val="1B1F24"/>
-                </a:solidFill>
-                <a:latin typeface="Inter" pitchFamily="34" charset="0"/>
-                <a:ea typeface="Inter" pitchFamily="34" charset="-122"/>
-                <a:cs typeface="Inter" pitchFamily="34" charset="-120"/>
-              </a:rPr>
-              <a:t>(Elkins et al., 2023)</a:t>
-            </a:r>
-            <a:endParaRPr lang="en-US" sz="1550" dirty="0"/>
-          </a:p>
-        </p:txBody>
-      </p:sp>
-      <p:sp>
-        <p:nvSpPr>
-          <p:cNvPr id="10" name="Shape 7"/>
+              <a:t>When teachers rated quiz questions drafted by AI, 97 in 100 were judged relevant to the topic they asked for. (Elkins et al., 2023)</a:t>
+            </a:r>
+            <a:endParaRPr lang="en-US" sz="1600" dirty="0"/>
+          </a:p>
+        </p:txBody>
+      </p:sp>
+      <p:sp>
+        <p:nvSpPr>
+          <p:cNvPr id="11" name="Shape 8"/>
           <p:cNvSpPr/>
           <p:nvPr/>
         </p:nvSpPr>
@@ -4869,14 +4874,14 @@
       </p:sp>
       <p:sp>
         <p:nvSpPr>
-          <p:cNvPr id="11" name="Text 8"/>
-          <p:cNvSpPr/>
-          <p:nvPr/>
-        </p:nvSpPr>
-        <p:spPr>
-          <a:xfrm>
-            <a:off x="6263640" y="1874520"/>
-            <a:ext cx="5257800" cy="1005840"/>
+          <p:cNvPr id="12" name="Text 9"/>
+          <p:cNvSpPr/>
+          <p:nvPr/>
+        </p:nvSpPr>
+        <p:spPr>
+          <a:xfrm>
+            <a:off x="6263640" y="1737360"/>
+            <a:ext cx="5257800" cy="292608"/>
           </a:xfrm>
           <a:prstGeom prst="rect">
             <a:avLst/>
@@ -4892,7 +4897,7 @@
               <a:buNone/>
             </a:pPr>
             <a:r>
-              <a:rPr lang="en-US" sz="5400" b="1" dirty="0">
+              <a:rPr lang="en-US" sz="1300" b="1" spc="200" kern="0" dirty="0">
                 <a:solidFill>
                   <a:srgbClr val="2A9D8F"/>
                 </a:solidFill>
@@ -4900,22 +4905,61 @@
                 <a:ea typeface="Inter" pitchFamily="34" charset="-122"/>
                 <a:cs typeface="Inter" pitchFamily="34" charset="-120"/>
               </a:rPr>
+              <a:t>HOW USEFUL TEACHERS FOUND THEM</a:t>
+            </a:r>
+            <a:endParaRPr lang="en-US" sz="1300" dirty="0"/>
+          </a:p>
+        </p:txBody>
+      </p:sp>
+      <p:sp>
+        <p:nvSpPr>
+          <p:cNvPr id="13" name="Text 10"/>
+          <p:cNvSpPr/>
+          <p:nvPr/>
+        </p:nvSpPr>
+        <p:spPr>
+          <a:xfrm>
+            <a:off x="6263640" y="2029968"/>
+            <a:ext cx="5257800" cy="868680"/>
+          </a:xfrm>
+          <a:prstGeom prst="rect">
+            <a:avLst/>
+          </a:prstGeom>
+          <a:noFill/>
+          <a:ln/>
+        </p:spPr>
+        <p:txBody>
+          <a:bodyPr wrap="square" lIns="0" tIns="0" rIns="0" bIns="0" rtlCol="0" anchor="ctr"/>
+          <a:lstStyle/>
+          <a:p>
+            <a:pPr algn="ctr" indent="0" marL="0">
+              <a:buNone/>
+            </a:pPr>
+            <a:r>
+              <a:rPr lang="en-US" sz="4800" b="1" dirty="0">
+                <a:solidFill>
+                  <a:srgbClr val="2A9D8F"/>
+                </a:solidFill>
+                <a:latin typeface="Inter" pitchFamily="34" charset="0"/>
+                <a:ea typeface="Inter" pitchFamily="34" charset="-122"/>
+                <a:cs typeface="Inter" pitchFamily="34" charset="-120"/>
+              </a:rPr>
               <a:t>3.6 / 4</a:t>
             </a:r>
-            <a:endParaRPr lang="en-US" sz="5400" dirty="0"/>
-          </a:p>
-        </p:txBody>
-      </p:sp>
-      <p:sp>
-        <p:nvSpPr>
-          <p:cNvPr id="12" name="Text 9"/>
-          <p:cNvSpPr/>
-          <p:nvPr/>
-        </p:nvSpPr>
-        <p:spPr>
-          <a:xfrm>
-            <a:off x="6537960" y="2926080"/>
-            <a:ext cx="4709160" cy="1371600"/>
+            <a:endParaRPr lang="en-US" sz="4800" dirty="0"/>
+          </a:p>
+        </p:txBody>
+      </p:sp>
+      <p:sp>
+        <p:nvSpPr>
+          <p:cNvPr id="14" name="Text 11"/>
+          <p:cNvSpPr/>
+          <p:nvPr/>
+        </p:nvSpPr>
+        <p:spPr>
+          <a:xfrm>
+            <a:off x="6537960" y="2971800"/>
+            <a:ext cx="4709160" cy="1463040"/>
           </a:xfrm>
           <a:prstGeom prst="rect">
             <a:avLst/>
@@ -4931,7 +4975,7 @@
               <a:buNone/>
             </a:pPr>
             <a:r>
-              <a:rPr lang="en-US" sz="1550" dirty="0">
+              <a:rPr lang="en-US" sz="1600" dirty="0">
                 <a:solidFill>
                   <a:srgbClr val="1B1F24"/>
                 </a:solidFill>
@@ -4939,49 +4983,15 @@
                 <a:ea typeface="Inter" pitchFamily="34" charset="-122"/>
                 <a:cs typeface="Inter" pitchFamily="34" charset="-120"/>
               </a:rPr>
-              <a:t>average usefulness rating,</a:t>
-            </a:r>
-            <a:endParaRPr lang="en-US" sz="1550" dirty="0"/>
-          </a:p>
-          <a:p>
-            <a:pPr algn="ctr" indent="0" marL="0">
-              <a:buNone/>
-            </a:pPr>
-            <a:r>
-              <a:rPr lang="en-US" sz="1550" dirty="0">
-                <a:solidFill>
-                  <a:srgbClr val="1B1F24"/>
-                </a:solidFill>
-                <a:latin typeface="Inter" pitchFamily="34" charset="0"/>
-                <a:ea typeface="Inter" pitchFamily="34" charset="-122"/>
-                <a:cs typeface="Inter" pitchFamily="34" charset="-120"/>
-              </a:rPr>
-              <a:t>with teacher vetting integral</a:t>
-            </a:r>
-            <a:endParaRPr lang="en-US" sz="1550" dirty="0"/>
-          </a:p>
-          <a:p>
-            <a:pPr algn="ctr" indent="0" marL="0">
-              <a:buNone/>
-            </a:pPr>
-            <a:r>
-              <a:rPr lang="en-US" sz="1550" dirty="0">
-                <a:solidFill>
-                  <a:srgbClr val="1B1F24"/>
-                </a:solidFill>
-                <a:latin typeface="Inter" pitchFamily="34" charset="0"/>
-                <a:ea typeface="Inter" pitchFamily="34" charset="-122"/>
-                <a:cs typeface="Inter" pitchFamily="34" charset="-120"/>
-              </a:rPr>
-              <a:t>(same study)</a:t>
-            </a:r>
-            <a:endParaRPr lang="en-US" sz="1550" dirty="0"/>
-          </a:p>
-        </p:txBody>
-      </p:sp>
-      <p:sp>
-        <p:nvSpPr>
-          <p:cNvPr id="13" name="Text 10"/>
+              <a:t>The same teachers scored the questions’ usefulness 3.6 out of 4, and the study treats teacher vetting as integral, not optional. (same study)</a:t>
+            </a:r>
+            <a:endParaRPr lang="en-US" sz="1600" dirty="0"/>
+          </a:p>
+        </p:txBody>
+      </p:sp>
+      <p:sp>
+        <p:nvSpPr>
+          <p:cNvPr id="15" name="Text 12"/>
           <p:cNvSpPr/>
           <p:nvPr/>
         </p:nvSpPr>

</xml_diff>

<commit_message>
Owner edit: no death metaphors for editing; weak questions are caught and cut
Replaces kill/dies/dead phrasing in the Kit 4 script and deck (lab ground
rules, vetting rep, inventory recap) with catch-and-cut language, and records
the rule in KIT_STANDARD voice so future kits follow it. All Kit 4 PDFs and
the deck rebuilt and re-inspected; zero die/kill/dead matches remain.

Co-Authored-By: Claude Fable 5 <noreply@anthropic.com>
Claude-Session: https://claude.ai/code/session_01EsE79TDyHfL767rcqG6D4Q
</commit_message>
<xml_diff>
--- a/kits/kit04/Kit04_PresentationDeck.pptx
+++ b/kits/kit04/Kit04_PresentationDeck.pptx
@@ -8056,7 +8056,7 @@
                 <a:ea typeface="Inter" pitchFamily="34" charset="-122"/>
                 <a:cs typeface="Inter" pitchFamily="34" charset="-120"/>
               </a:rPr>
-              <a:t>At least one weak question dies by your hand before the lab ends</a:t>
+              <a:t>You catch and cut at least one weak question before the lab ends</a:t>
             </a:r>
             <a:endParaRPr lang="en-US" sz="2000" dirty="0"/>
           </a:p>
@@ -11014,7 +11014,7 @@
                 <a:ea typeface="Inter" pitchFamily="34" charset="-122"/>
                 <a:cs typeface="Inter" pitchFamily="34" charset="-120"/>
               </a:rPr>
-              <a:t>A four-level rubric a student can read. A vetted question bank with a checked answer key. Three feedback starters for the comments you write most. One dead weak question as proof the reflex works.
+              <a:t>A four-level rubric a student can read. A vetted question bank with a checked answer key. Three feedback starters for the comments you write most. One weak question caught and cut as proof the reflex works.
 </a:t>
             </a:r>
             <a:pPr indent="0" marL="0">

</xml_diff>

<commit_message>
Kit 4: universal lab-exemplar retrofit (owner directive)
Ms. Rivera follows one artifact through the whole lab: her upcoming
persuasive essay assessment, from rubric to vetted question bank to
feedback starters. Deck slides 19-22 carry her work as large teal
exemplar cards; chips and script rivera-lines name the same essay at
every step. Slide 21's title resized to clear the chip zone.

Co-Authored-By: Claude Fable 5 <noreply@anthropic.com>
Claude-Session: https://claude.ai/code/session_019agQ42s1igQaB2X7GGat9R
</commit_message>
<xml_diff>
--- a/kits/kit04/Kit04_PresentationDeck.pptx
+++ b/kits/kit04/Kit04_PresentationDeck.pptx
@@ -1323,7 +1323,7 @@
           <a:p>
             <a:r>
               <a:rPr lang="en-US" dirty="0"/>
-              <a:t>Pairs, devices out inside two minutes, announce the tool. If you grade with a rubric of your own, show it here; one real rubric from a real room tells the lab what "done" looks like.</a:t>
+              <a:t>Pairs, devices out inside two minutes, announce the tool. Ms. Rivera builds for ONE assessment across all three steps: her 7th grade persuasive essay, the same one from workshop 1. Her exemplar appears large on every step slide; anyone lost can copy her structure. If you grade with a rubric of your own, show it here; one real rubric from a real room tells the lab what "done" looks like.</a:t>
             </a:r>
             <a:endParaRPr lang="en-US" dirty="0"/>
           </a:p>
@@ -1411,7 +1411,7 @@
           <a:p>
             <a:r>
               <a:rPr lang="en-US" dirty="0"/>
-              <a:t>Circulate. Weak rubrics are usually missing the teacher’s notes; nudge with "what do you actually look for when you grade this? Type that."</a:t>
+              <a:t>Circulate. Weak rubrics are usually missing the teacher’s notes; nudge with "what do you actually look for when you grade this? Type that." The big card is Ms. Rivera's persuasive-essay rubric mid-build, the same assessment she carries through all three steps: her messy note went in, a readable level-4 descriptor came out. Anyone stuck can copy that shape with their own notes.</a:t>
             </a:r>
             <a:endParaRPr lang="en-US" dirty="0"/>
           </a:p>
@@ -1587,7 +1587,7 @@
           <a:p>
             <a:r>
               <a:rPr lang="en-US" dirty="0"/>
-              <a:t>45-min cut: six questions instead of ten. Listen for the misconception sentences; they’re the best writing that happens all day.</a:t>
+              <a:t>45-min cut: six questions instead of ten. Listen for the misconception sentences; they’re the best writing that happens all day. The big card is Ms. Rivera's bank for the same persuasive essay: her misconception sentence went into the prompt, and one distractor now restates the claim, exactly the mix-up her students make. Mimic her sentence with your own X and Y.</a:t>
             </a:r>
             <a:endParaRPr lang="en-US" dirty="0"/>
           </a:p>
@@ -1675,7 +1675,7 @@
           <a:p>
             <a:r>
               <a:rPr lang="en-US" dirty="0"/>
-              <a:t>This rep is a requirement, not a suggestion: it installs the habit that makes the whole workflow safe. Celebrate every catch audibly.</a:t>
+              <a:t>This rep is a requirement, not a suggestion: it installs the habit that makes the whole workflow safe. The big card shows Ms. Rivera's catch in her own essay bank: a question with two defensible answers, cut and rewritten by hand. Celebrate every catch audibly.</a:t>
             </a:r>
             <a:endParaRPr lang="en-US" dirty="0"/>
           </a:p>
@@ -1763,7 +1763,7 @@
           <a:p>
             <a:r>
               <a:rPr lang="en-US" dirty="0"/>
-              <a:t>If someone starts pasting a student’s work, redirect gently: describe the pattern instead; excerpts only if fully anonymous by Kit 1’s test.</a:t>
+              <a:t>If someone starts pasting a student’s work, redirect gently: describe the pattern instead; excerpts only if fully anonymous by Kit 1’s test. The big card is one of Ms. Rivera's three starters for the same persuasive essay: strength, pattern, next step, in words a 7th grader can read. Copy its shape for your own patterns.</a:t>
             </a:r>
             <a:endParaRPr lang="en-US" dirty="0"/>
           </a:p>
@@ -9493,7 +9493,7 @@
                 <a:ea typeface="Inter" pitchFamily="34" charset="-122"/>
                 <a:cs typeface="Inter" pitchFamily="34" charset="-120"/>
               </a:rPr>
-              <a:t>Her lab: the assessment on her calendar, materials built tonight-free.</a:t>
+              <a:t>Her lab pick, one assessment through every step: her persuasive essay.</a:t>
             </a:r>
             <a:endParaRPr lang="en-US" sz="1000" dirty="0"/>
           </a:p>
@@ -10274,7 +10274,7 @@
                 <a:ea typeface="Inter" pitchFamily="34" charset="-122"/>
                 <a:cs typeface="Inter" pitchFamily="34" charset="-120"/>
               </a:rPr>
-              <a:t>On her screen: notes in, rubric out, hand-it-to-a-student pass next.</a:t>
+              <a:t>Her essay rubric, on screen big: messy notes in, four readable levels out.</a:t>
             </a:r>
             <a:endParaRPr lang="en-US" sz="1000" dirty="0"/>
           </a:p>
@@ -10328,7 +10328,7 @@
         <p:spPr>
           <a:xfrm>
             <a:off x="548640" y="384048"/>
-            <a:ext cx="11091672" cy="777240"/>
+            <a:ext cx="7955280" cy="777240"/>
           </a:xfrm>
           <a:prstGeom prst="rect">
             <a:avLst/>
@@ -10360,26 +10360,132 @@
       </p:sp>
       <p:sp>
         <p:nvSpPr>
-          <p:cNvPr id="14" name="Shape 11"/>
-          <p:cNvSpPr/>
-          <p:nvPr/>
-        </p:nvSpPr>
-        <p:spPr>
-          <a:xfrm>
-            <a:off x="640080" y="1508760"/>
-            <a:ext cx="10972800" cy="731520"/>
+          <p:cNvPr id="14" name="Text 11"/>
+          <p:cNvSpPr/>
+          <p:nvPr/>
+        </p:nvSpPr>
+        <p:spPr>
+          <a:xfrm>
+            <a:off x="640080" y="1554480"/>
+            <a:ext cx="5394960" cy="3566160"/>
+          </a:xfrm>
+          <a:prstGeom prst="rect">
+            <a:avLst/>
+          </a:prstGeom>
+          <a:noFill/>
+          <a:ln/>
+        </p:spPr>
+        <p:txBody>
+          <a:bodyPr wrap="square" rtlCol="0" anchor="t"/>
+          <a:lstStyle/>
+          <a:p>
+            <a:pPr marL="342900" indent="-342900">
+              <a:spcAft>
+                <a:spcPts val="1000"/>
+              </a:spcAft>
+              <a:buSzPct val="100000"/>
+              <a:buChar char="•"/>
+            </a:pPr>
+            <a:r>
+              <a:rPr lang="en-US" sz="1600" dirty="0">
+                <a:solidFill>
+                  <a:srgbClr val="1B1F24"/>
+                </a:solidFill>
+                <a:latin typeface="Inter" pitchFamily="34" charset="0"/>
+                <a:ea typeface="Inter" pitchFamily="34" charset="-122"/>
+                <a:cs typeface="Inter" pitchFamily="34" charset="-120"/>
+              </a:rPr>
+              <a:t>Run the rubric prompt with your grade, subject, criteria, and pasted notes</a:t>
+            </a:r>
+            <a:endParaRPr lang="en-US" sz="1600" dirty="0"/>
+          </a:p>
+          <a:p>
+            <a:pPr marL="342900" indent="-342900">
+              <a:spcAft>
+                <a:spcPts val="1000"/>
+              </a:spcAft>
+              <a:buSzPct val="100000"/>
+              <a:buChar char="•"/>
+            </a:pPr>
+            <a:r>
+              <a:rPr lang="en-US" sz="1600" dirty="0">
+                <a:solidFill>
+                  <a:srgbClr val="1B1F24"/>
+                </a:solidFill>
+                <a:latin typeface="Inter" pitchFamily="34" charset="0"/>
+                <a:ea typeface="Inter" pitchFamily="34" charset="-122"/>
+                <a:cs typeface="Inter" pitchFamily="34" charset="-120"/>
+              </a:rPr>
+              <a:t>Content round: are these the right criteria? Is anything you actually grade for missing?</a:t>
+            </a:r>
+            <a:endParaRPr lang="en-US" sz="1600" dirty="0"/>
+          </a:p>
+          <a:p>
+            <a:pPr marL="342900" indent="-342900">
+              <a:spcAft>
+                <a:spcPts val="1000"/>
+              </a:spcAft>
+              <a:buSzPct val="100000"/>
+              <a:buChar char="•"/>
+            </a:pPr>
+            <a:r>
+              <a:rPr lang="en-US" sz="1600" dirty="0">
+                <a:solidFill>
+                  <a:srgbClr val="1B1F24"/>
+                </a:solidFill>
+                <a:latin typeface="Inter" pitchFamily="34" charset="0"/>
+                <a:ea typeface="Inter" pitchFamily="34" charset="-122"/>
+                <a:cs typeface="Inter" pitchFamily="34" charset="-120"/>
+              </a:rPr>
+              <a:t>Voice round: the hand-it-to-a-student test, on every descriptor</a:t>
+            </a:r>
+            <a:endParaRPr lang="en-US" sz="1600" dirty="0"/>
+          </a:p>
+          <a:p>
+            <a:pPr marL="342900" indent="-342900">
+              <a:spcAft>
+                <a:spcPts val="1000"/>
+              </a:spcAft>
+              <a:buSzPct val="100000"/>
+              <a:buChar char="•"/>
+            </a:pPr>
+            <a:r>
+              <a:rPr lang="en-US" sz="1600" dirty="0">
+                <a:solidFill>
+                  <a:srgbClr val="1B1F24"/>
+                </a:solidFill>
+                <a:latin typeface="Inter" pitchFamily="34" charset="0"/>
+                <a:ea typeface="Inter" pitchFamily="34" charset="-122"/>
+                <a:cs typeface="Inter" pitchFamily="34" charset="-120"/>
+              </a:rPr>
+              <a:t>Details round: table format, level names, point values if you use them</a:t>
+            </a:r>
+            <a:endParaRPr lang="en-US" sz="1600" dirty="0"/>
+          </a:p>
+        </p:txBody>
+      </p:sp>
+      <p:sp>
+        <p:nvSpPr>
+          <p:cNvPr id="15" name="Shape 12"/>
+          <p:cNvSpPr/>
+          <p:nvPr/>
+        </p:nvSpPr>
+        <p:spPr>
+          <a:xfrm>
+            <a:off x="6263640" y="1554480"/>
+            <a:ext cx="5394960" cy="3566160"/>
           </a:xfrm>
           <a:prstGeom prst="roundRect">
             <a:avLst>
-              <a:gd name="adj" fmla="val 11250"/>
+              <a:gd name="adj" fmla="val 2308"/>
             </a:avLst>
           </a:prstGeom>
           <a:solidFill>
-            <a:srgbClr val="F7F5F0"/>
+            <a:srgbClr val="EAF5F3"/>
           </a:solidFill>
           <a:ln w="12700">
             <a:solidFill>
-              <a:srgbClr val="F7F5F0"/>
+              <a:srgbClr val="EAF5F3"/>
             </a:solidFill>
             <a:prstDash val="solid"/>
           </a:ln>
@@ -10387,30 +10493,89 @@
       </p:sp>
       <p:sp>
         <p:nvSpPr>
-          <p:cNvPr id="15" name="Text 12"/>
-          <p:cNvSpPr/>
-          <p:nvPr/>
-        </p:nvSpPr>
-        <p:spPr>
-          <a:xfrm>
-            <a:off x="960120" y="1563624"/>
-            <a:ext cx="10332720" cy="621792"/>
-          </a:xfrm>
-          <a:prstGeom prst="rect">
-            <a:avLst/>
-          </a:prstGeom>
-          <a:noFill/>
-          <a:ln/>
-        </p:spPr>
-        <p:txBody>
-          <a:bodyPr wrap="square" lIns="0" tIns="0" rIns="0" bIns="0" rtlCol="0" anchor="ctr"/>
-          <a:lstStyle/>
-          <a:p>
-            <a:pPr indent="0" marL="0">
-              <a:buNone/>
-            </a:pPr>
-            <a:r>
-              <a:rPr lang="en-US" sz="1800" dirty="0">
+          <p:cNvPr id="16" name="Text 13"/>
+          <p:cNvSpPr/>
+          <p:nvPr/>
+        </p:nvSpPr>
+        <p:spPr>
+          <a:xfrm>
+            <a:off x="6537960" y="1737360"/>
+            <a:ext cx="4937760" cy="292608"/>
+          </a:xfrm>
+          <a:prstGeom prst="rect">
+            <a:avLst/>
+          </a:prstGeom>
+          <a:noFill/>
+          <a:ln/>
+        </p:spPr>
+        <p:txBody>
+          <a:bodyPr wrap="square" lIns="0" tIns="0" rIns="0" bIns="0" rtlCol="0" anchor="ctr"/>
+          <a:lstStyle/>
+          <a:p>
+            <a:pPr indent="0" marL="0">
+              <a:buNone/>
+            </a:pPr>
+            <a:r>
+              <a:rPr lang="en-US" sz="1250" b="1" spc="150" kern="0" dirty="0">
+                <a:solidFill>
+                  <a:srgbClr val="2A9D8F"/>
+                </a:solidFill>
+                <a:latin typeface="Inter" pitchFamily="34" charset="0"/>
+                <a:ea typeface="Inter" pitchFamily="34" charset="-122"/>
+                <a:cs typeface="Inter" pitchFamily="34" charset="-120"/>
+              </a:rPr>
+              <a:t>MS. RIVERA'S ESSAY · STEP 1 · HER RUBRIC</a:t>
+            </a:r>
+            <a:endParaRPr lang="en-US" sz="1250" dirty="0"/>
+          </a:p>
+        </p:txBody>
+      </p:sp>
+      <p:sp>
+        <p:nvSpPr>
+          <p:cNvPr id="17" name="Text 14"/>
+          <p:cNvSpPr/>
+          <p:nvPr/>
+        </p:nvSpPr>
+        <p:spPr>
+          <a:xfrm>
+            <a:off x="6537960" y="2148840"/>
+            <a:ext cx="4892040" cy="2834640"/>
+          </a:xfrm>
+          <a:prstGeom prst="rect">
+            <a:avLst/>
+          </a:prstGeom>
+          <a:noFill/>
+          <a:ln/>
+        </p:spPr>
+        <p:txBody>
+          <a:bodyPr wrap="square" lIns="0" tIns="0" rIns="0" bIns="0" rtlCol="0" anchor="t"/>
+          <a:lstStyle/>
+          <a:p>
+            <a:pPr indent="0" marL="0">
+              <a:lnSpc>
+                <a:spcPct val="120000"/>
+              </a:lnSpc>
+              <a:buNone/>
+            </a:pPr>
+            <a:r>
+              <a:rPr lang="en-US" sz="1600" b="1" dirty="0">
+                <a:solidFill>
+                  <a:srgbClr val="13293D"/>
+                </a:solidFill>
+                <a:latin typeface="Inter" pitchFamily="34" charset="0"/>
+                <a:ea typeface="Inter" pitchFamily="34" charset="-122"/>
+                <a:cs typeface="Inter" pitchFamily="34" charset="-120"/>
+              </a:rPr>
+              <a:t>Her note: </a:t>
+            </a:r>
+            <a:pPr indent="0" marL="0">
+              <a:lnSpc>
+                <a:spcPct val="120000"/>
+              </a:lnSpc>
+              <a:buNone/>
+            </a:pPr>
+            <a:r>
+              <a:rPr lang="en-US" sz="1600" i="1" dirty="0">
                 <a:solidFill>
                   <a:srgbClr val="1B1F24"/>
                 </a:solidFill>
@@ -10418,65 +10583,34 @@
                 <a:ea typeface="Inter" pitchFamily="34" charset="-122"/>
                 <a:cs typeface="Inter" pitchFamily="34" charset="-120"/>
               </a:rPr>
-              <a:t>Run the rubric prompt with your grade, subject, criteria, and pasted notes</a:t>
-            </a:r>
-            <a:endParaRPr lang="en-US" sz="1800" dirty="0"/>
-          </a:p>
-        </p:txBody>
-      </p:sp>
-      <p:sp>
-        <p:nvSpPr>
-          <p:cNvPr id="16" name="Shape 13"/>
-          <p:cNvSpPr/>
-          <p:nvPr/>
-        </p:nvSpPr>
-        <p:spPr>
-          <a:xfrm>
-            <a:off x="640080" y="2377440"/>
-            <a:ext cx="10972800" cy="731520"/>
-          </a:xfrm>
-          <a:prstGeom prst="roundRect">
-            <a:avLst>
-              <a:gd name="adj" fmla="val 11250"/>
-            </a:avLst>
-          </a:prstGeom>
-          <a:solidFill>
-            <a:srgbClr val="F7F5F0"/>
-          </a:solidFill>
-          <a:ln w="12700">
-            <a:solidFill>
-              <a:srgbClr val="F7F5F0"/>
-            </a:solidFill>
-            <a:prstDash val="solid"/>
-          </a:ln>
-        </p:spPr>
-      </p:sp>
-      <p:sp>
-        <p:nvSpPr>
-          <p:cNvPr id="17" name="Text 14"/>
-          <p:cNvSpPr/>
-          <p:nvPr/>
-        </p:nvSpPr>
-        <p:spPr>
-          <a:xfrm>
-            <a:off x="960120" y="2432304"/>
-            <a:ext cx="10332720" cy="621792"/>
-          </a:xfrm>
-          <a:prstGeom prst="rect">
-            <a:avLst/>
-          </a:prstGeom>
-          <a:noFill/>
-          <a:ln/>
-        </p:spPr>
-        <p:txBody>
-          <a:bodyPr wrap="square" lIns="0" tIns="0" rIns="0" bIns="0" rtlCol="0" anchor="ctr"/>
-          <a:lstStyle/>
-          <a:p>
-            <a:pPr indent="0" marL="0">
-              <a:buNone/>
-            </a:pPr>
-            <a:r>
-              <a:rPr lang="en-US" sz="1800" dirty="0">
+              <a:t>"an A backs every claim and says why the evidence matters."
+</a:t>
+            </a:r>
+            <a:pPr indent="0" marL="0">
+              <a:lnSpc>
+                <a:spcPct val="120000"/>
+              </a:lnSpc>
+              <a:buNone/>
+            </a:pPr>
+            <a:r>
+              <a:rPr lang="en-US" sz="1600" b="1" dirty="0">
+                <a:solidFill>
+                  <a:srgbClr val="13293D"/>
+                </a:solidFill>
+                <a:latin typeface="Inter" pitchFamily="34" charset="0"/>
+                <a:ea typeface="Inter" pitchFamily="34" charset="-122"/>
+                <a:cs typeface="Inter" pitchFamily="34" charset="-120"/>
+              </a:rPr>
+              <a:t>Level 4 · Evidence: </a:t>
+            </a:r>
+            <a:pPr indent="0" marL="0">
+              <a:lnSpc>
+                <a:spcPct val="120000"/>
+              </a:lnSpc>
+              <a:buNone/>
+            </a:pPr>
+            <a:r>
+              <a:rPr lang="en-US" sz="1600" dirty="0">
                 <a:solidFill>
                   <a:srgbClr val="1B1F24"/>
                 </a:solidFill>
@@ -10484,153 +10618,39 @@
                 <a:ea typeface="Inter" pitchFamily="34" charset="-122"/>
                 <a:cs typeface="Inter" pitchFamily="34" charset="-120"/>
               </a:rPr>
-              <a:t>Content round: are these the right criteria? Is anything you actually grade for missing?</a:t>
-            </a:r>
-            <a:endParaRPr lang="en-US" sz="1800" dirty="0"/>
-          </a:p>
-        </p:txBody>
-      </p:sp>
-      <p:sp>
-        <p:nvSpPr>
-          <p:cNvPr id="18" name="Shape 15"/>
-          <p:cNvSpPr/>
-          <p:nvPr/>
-        </p:nvSpPr>
-        <p:spPr>
-          <a:xfrm>
-            <a:off x="640080" y="3246120"/>
-            <a:ext cx="10972800" cy="731520"/>
-          </a:xfrm>
-          <a:prstGeom prst="roundRect">
-            <a:avLst>
-              <a:gd name="adj" fmla="val 11250"/>
-            </a:avLst>
-          </a:prstGeom>
-          <a:solidFill>
-            <a:srgbClr val="F7F5F0"/>
-          </a:solidFill>
-          <a:ln w="12700">
-            <a:solidFill>
-              <a:srgbClr val="F7F5F0"/>
-            </a:solidFill>
-            <a:prstDash val="solid"/>
-          </a:ln>
-        </p:spPr>
-      </p:sp>
-      <p:sp>
-        <p:nvSpPr>
-          <p:cNvPr id="19" name="Text 16"/>
-          <p:cNvSpPr/>
-          <p:nvPr/>
-        </p:nvSpPr>
-        <p:spPr>
-          <a:xfrm>
-            <a:off x="960120" y="3300984"/>
-            <a:ext cx="10332720" cy="621792"/>
-          </a:xfrm>
-          <a:prstGeom prst="rect">
-            <a:avLst/>
-          </a:prstGeom>
-          <a:noFill/>
-          <a:ln/>
-        </p:spPr>
-        <p:txBody>
-          <a:bodyPr wrap="square" lIns="0" tIns="0" rIns="0" bIns="0" rtlCol="0" anchor="ctr"/>
-          <a:lstStyle/>
-          <a:p>
-            <a:pPr indent="0" marL="0">
-              <a:buNone/>
-            </a:pPr>
-            <a:r>
-              <a:rPr lang="en-US" sz="1800" dirty="0">
-                <a:solidFill>
-                  <a:srgbClr val="1B1F24"/>
-                </a:solidFill>
-                <a:latin typeface="Inter" pitchFamily="34" charset="0"/>
-                <a:ea typeface="Inter" pitchFamily="34" charset="-122"/>
-                <a:cs typeface="Inter" pitchFamily="34" charset="-120"/>
-              </a:rPr>
-              <a:t>Voice round: the hand-it-to-a-student test, on every descriptor</a:t>
-            </a:r>
-            <a:endParaRPr lang="en-US" sz="1800" dirty="0"/>
-          </a:p>
-        </p:txBody>
-      </p:sp>
-      <p:sp>
-        <p:nvSpPr>
-          <p:cNvPr id="20" name="Shape 17"/>
-          <p:cNvSpPr/>
-          <p:nvPr/>
-        </p:nvSpPr>
-        <p:spPr>
-          <a:xfrm>
-            <a:off x="640080" y="4114800"/>
-            <a:ext cx="10972800" cy="731520"/>
-          </a:xfrm>
-          <a:prstGeom prst="roundRect">
-            <a:avLst>
-              <a:gd name="adj" fmla="val 11250"/>
-            </a:avLst>
-          </a:prstGeom>
-          <a:solidFill>
-            <a:srgbClr val="F7F5F0"/>
-          </a:solidFill>
-          <a:ln w="12700">
-            <a:solidFill>
-              <a:srgbClr val="F7F5F0"/>
-            </a:solidFill>
-            <a:prstDash val="solid"/>
-          </a:ln>
-        </p:spPr>
-      </p:sp>
-      <p:sp>
-        <p:nvSpPr>
-          <p:cNvPr id="21" name="Text 18"/>
-          <p:cNvSpPr/>
-          <p:nvPr/>
-        </p:nvSpPr>
-        <p:spPr>
-          <a:xfrm>
-            <a:off x="960120" y="4169664"/>
-            <a:ext cx="10332720" cy="621792"/>
-          </a:xfrm>
-          <a:prstGeom prst="rect">
-            <a:avLst/>
-          </a:prstGeom>
-          <a:noFill/>
-          <a:ln/>
-        </p:spPr>
-        <p:txBody>
-          <a:bodyPr wrap="square" lIns="0" tIns="0" rIns="0" bIns="0" rtlCol="0" anchor="ctr"/>
-          <a:lstStyle/>
-          <a:p>
-            <a:pPr indent="0" marL="0">
-              <a:buNone/>
-            </a:pPr>
-            <a:r>
-              <a:rPr lang="en-US" sz="1800" dirty="0">
-                <a:solidFill>
-                  <a:srgbClr val="1B1F24"/>
-                </a:solidFill>
-                <a:latin typeface="Inter" pitchFamily="34" charset="0"/>
-                <a:ea typeface="Inter" pitchFamily="34" charset="-122"/>
-                <a:cs typeface="Inter" pitchFamily="34" charset="-120"/>
-              </a:rPr>
-              <a:t>Details round: table format, level names, point values if you use them</a:t>
-            </a:r>
-            <a:endParaRPr lang="en-US" sz="1800" dirty="0"/>
-          </a:p>
-        </p:txBody>
-      </p:sp>
-      <p:sp>
-        <p:nvSpPr>
-          <p:cNvPr id="22" name="Text 19"/>
-          <p:cNvSpPr/>
-          <p:nvPr/>
-        </p:nvSpPr>
-        <p:spPr>
-          <a:xfrm>
-            <a:off x="640080" y="5212080"/>
+              <a:t>"Every claim has a quote or fact behind it, and you explain why it proves your point."
+</a:t>
+            </a:r>
+            <a:pPr indent="0" marL="0">
+              <a:lnSpc>
+                <a:spcPct val="120000"/>
+              </a:lnSpc>
+              <a:buNone/>
+            </a:pPr>
+            <a:r>
+              <a:rPr lang="en-US" sz="1600" i="1" dirty="0">
+                <a:solidFill>
+                  <a:srgbClr val="5B6B7A"/>
+                </a:solidFill>
+                <a:latin typeface="Inter" pitchFamily="34" charset="0"/>
+                <a:ea typeface="Inter" pitchFamily="34" charset="-122"/>
+                <a:cs typeface="Inter" pitchFamily="34" charset="-120"/>
+              </a:rPr>
+              <a:t>Passed the hand-it-to-a-student test on round two.</a:t>
+            </a:r>
+            <a:endParaRPr lang="en-US" sz="1600" dirty="0"/>
+          </a:p>
+        </p:txBody>
+      </p:sp>
+      <p:sp>
+        <p:nvSpPr>
+          <p:cNvPr id="18" name="Text 15"/>
+          <p:cNvSpPr/>
+          <p:nvPr/>
+        </p:nvSpPr>
+        <p:spPr>
+          <a:xfrm>
+            <a:off x="640080" y="5349240"/>
             <a:ext cx="10972800" cy="457200"/>
           </a:xfrm>
           <a:prstGeom prst="rect">
@@ -11760,7 +11780,7 @@
                 <a:ea typeface="Inter" pitchFamily="34" charset="-122"/>
                 <a:cs typeface="Inter" pitchFamily="34" charset="-120"/>
               </a:rPr>
-              <a:t>Her bank: ten questions, misconception distractors, key checked.</a:t>
+              <a:t>Her essay bank, on screen: the claim-repeat confusion built into a distractor.</a:t>
             </a:r>
             <a:endParaRPr lang="en-US" sz="1000" dirty="0"/>
           </a:p>
@@ -11814,7 +11834,7 @@
         <p:spPr>
           <a:xfrm>
             <a:off x="548640" y="384048"/>
-            <a:ext cx="11091672" cy="777240"/>
+            <a:ext cx="7955280" cy="777240"/>
           </a:xfrm>
           <a:prstGeom prst="rect">
             <a:avLst/>
@@ -11852,8 +11872,8 @@
         </p:nvSpPr>
         <p:spPr>
           <a:xfrm>
-            <a:off x="640080" y="1463040"/>
-            <a:ext cx="10908792" cy="2377440"/>
+            <a:off x="640080" y="1554480"/>
+            <a:ext cx="5394960" cy="3566160"/>
           </a:xfrm>
           <a:prstGeom prst="rect">
             <a:avLst/>
@@ -11873,7 +11893,7 @@
               <a:buChar char="•"/>
             </a:pPr>
             <a:r>
-              <a:rPr lang="en-US" sz="2100" dirty="0">
+              <a:rPr lang="en-US" sz="1600" dirty="0">
                 <a:solidFill>
                   <a:srgbClr val="1B1F24"/>
                 </a:solidFill>
@@ -11883,7 +11903,7 @@
               </a:rPr>
               <a:t>Same assessment: 10 questions, mixed format, full answer key, distractor rationale</a:t>
             </a:r>
-            <a:endParaRPr lang="en-US" sz="2100" dirty="0"/>
+            <a:endParaRPr lang="en-US" sz="1600" dirty="0"/>
           </a:p>
           <a:p>
             <a:pPr marL="342900" indent="-342900">
@@ -11894,7 +11914,7 @@
               <a:buChar char="•"/>
             </a:pPr>
             <a:r>
-              <a:rPr lang="en-US" sz="2100" b="1" dirty="0">
+              <a:rPr lang="en-US" sz="1600" b="1" dirty="0">
                 <a:solidFill>
                   <a:srgbClr val="13293D"/>
                 </a:solidFill>
@@ -11904,7 +11924,7 @@
               </a:rPr>
               <a:t>First, finish this sentence: “My students keep confusing X with Y.”</a:t>
             </a:r>
-            <a:endParaRPr lang="en-US" sz="2100" dirty="0"/>
+            <a:endParaRPr lang="en-US" sz="1600" dirty="0"/>
           </a:p>
           <a:p>
             <a:pPr marL="342900" indent="-342900">
@@ -11915,7 +11935,7 @@
               <a:buChar char="•"/>
             </a:pPr>
             <a:r>
-              <a:rPr lang="en-US" sz="2100" dirty="0">
+              <a:rPr lang="en-US" sz="1600" dirty="0">
                 <a:solidFill>
                   <a:srgbClr val="1B1F24"/>
                 </a:solidFill>
@@ -11925,7 +11945,7 @@
               </a:rPr>
               <a:t>Put that sentence in the prompt and make the misconception a distractor</a:t>
             </a:r>
-            <a:endParaRPr lang="en-US" sz="2100" dirty="0"/>
+            <a:endParaRPr lang="en-US" sz="1600" dirty="0"/>
           </a:p>
         </p:txBody>
       </p:sp>
@@ -11937,12 +11957,12 @@
         </p:nvSpPr>
         <p:spPr>
           <a:xfrm>
-            <a:off x="640080" y="4023360"/>
-            <a:ext cx="10972800" cy="1554480"/>
+            <a:off x="6263640" y="1554480"/>
+            <a:ext cx="5394960" cy="3566160"/>
           </a:xfrm>
           <a:prstGeom prst="roundRect">
             <a:avLst>
-              <a:gd name="adj" fmla="val 5294"/>
+              <a:gd name="adj" fmla="val 2308"/>
             </a:avLst>
           </a:prstGeom>
           <a:solidFill>
@@ -11964,24 +11984,66 @@
         </p:nvSpPr>
         <p:spPr>
           <a:xfrm>
-            <a:off x="960120" y="4251960"/>
-            <a:ext cx="10332720" cy="1097280"/>
-          </a:xfrm>
-          <a:prstGeom prst="rect">
-            <a:avLst/>
-          </a:prstGeom>
-          <a:noFill/>
-          <a:ln/>
-        </p:spPr>
-        <p:txBody>
-          <a:bodyPr wrap="square" lIns="0" tIns="0" rIns="0" bIns="0" rtlCol="0" anchor="ctr"/>
-          <a:lstStyle/>
-          <a:p>
-            <a:pPr indent="0" marL="0">
-              <a:buNone/>
-            </a:pPr>
-            <a:r>
-              <a:rPr lang="en-US" sz="2400" b="1" dirty="0">
+            <a:off x="6537960" y="1737360"/>
+            <a:ext cx="4937760" cy="292608"/>
+          </a:xfrm>
+          <a:prstGeom prst="rect">
+            <a:avLst/>
+          </a:prstGeom>
+          <a:noFill/>
+          <a:ln/>
+        </p:spPr>
+        <p:txBody>
+          <a:bodyPr wrap="square" lIns="0" tIns="0" rIns="0" bIns="0" rtlCol="0" anchor="ctr"/>
+          <a:lstStyle/>
+          <a:p>
+            <a:pPr indent="0" marL="0">
+              <a:buNone/>
+            </a:pPr>
+            <a:r>
+              <a:rPr lang="en-US" sz="1250" b="1" spc="150" kern="0" dirty="0">
+                <a:solidFill>
+                  <a:srgbClr val="2A9D8F"/>
+                </a:solidFill>
+                <a:latin typeface="Inter" pitchFamily="34" charset="0"/>
+                <a:ea typeface="Inter" pitchFamily="34" charset="-122"/>
+                <a:cs typeface="Inter" pitchFamily="34" charset="-120"/>
+              </a:rPr>
+              <a:t>MS. RIVERA'S ESSAY · STEP 2 · HER BANK</a:t>
+            </a:r>
+            <a:endParaRPr lang="en-US" sz="1250" dirty="0"/>
+          </a:p>
+        </p:txBody>
+      </p:sp>
+      <p:sp>
+        <p:nvSpPr>
+          <p:cNvPr id="17" name="Text 14"/>
+          <p:cNvSpPr/>
+          <p:nvPr/>
+        </p:nvSpPr>
+        <p:spPr>
+          <a:xfrm>
+            <a:off x="6537960" y="2148840"/>
+            <a:ext cx="4892040" cy="2834640"/>
+          </a:xfrm>
+          <a:prstGeom prst="rect">
+            <a:avLst/>
+          </a:prstGeom>
+          <a:noFill/>
+          <a:ln/>
+        </p:spPr>
+        <p:txBody>
+          <a:bodyPr wrap="square" lIns="0" tIns="0" rIns="0" bIns="0" rtlCol="0" anchor="t"/>
+          <a:lstStyle/>
+          <a:p>
+            <a:pPr indent="0" marL="0">
+              <a:lnSpc>
+                <a:spcPct val="120000"/>
+              </a:lnSpc>
+              <a:buNone/>
+            </a:pPr>
+            <a:r>
+              <a:rPr lang="en-US" sz="1600" b="1" dirty="0">
                 <a:solidFill>
                   <a:srgbClr val="13293D"/>
                 </a:solidFill>
@@ -11989,9 +12051,145 @@
                 <a:ea typeface="Inter" pitchFamily="34" charset="-122"/>
                 <a:cs typeface="Inter" pitchFamily="34" charset="-120"/>
               </a:rPr>
+              <a:t>Her sentence: </a:t>
+            </a:r>
+            <a:pPr indent="0" marL="0">
+              <a:lnSpc>
+                <a:spcPct val="120000"/>
+              </a:lnSpc>
+              <a:buNone/>
+            </a:pPr>
+            <a:r>
+              <a:rPr lang="en-US" sz="1600" i="1" dirty="0">
+                <a:solidFill>
+                  <a:srgbClr val="1B1F24"/>
+                </a:solidFill>
+                <a:latin typeface="Inter" pitchFamily="34" charset="0"/>
+                <a:ea typeface="Inter" pitchFamily="34" charset="-122"/>
+                <a:cs typeface="Inter" pitchFamily="34" charset="-120"/>
+              </a:rPr>
+              <a:t>"My students keep confusing restating the claim with giving evidence."
+</a:t>
+            </a:r>
+            <a:pPr indent="0" marL="0">
+              <a:lnSpc>
+                <a:spcPct val="120000"/>
+              </a:lnSpc>
+              <a:buNone/>
+            </a:pPr>
+            <a:r>
+              <a:rPr lang="en-US" sz="1600" b="1" dirty="0">
+                <a:solidFill>
+                  <a:srgbClr val="13293D"/>
+                </a:solidFill>
+                <a:latin typeface="Inter" pitchFamily="34" charset="0"/>
+                <a:ea typeface="Inter" pitchFamily="34" charset="-122"/>
+                <a:cs typeface="Inter" pitchFamily="34" charset="-120"/>
+              </a:rPr>
+              <a:t>Q4: </a:t>
+            </a:r>
+            <a:pPr indent="0" marL="0">
+              <a:lnSpc>
+                <a:spcPct val="120000"/>
+              </a:lnSpc>
+              <a:buNone/>
+            </a:pPr>
+            <a:r>
+              <a:rPr lang="en-US" sz="1600" dirty="0">
+                <a:solidFill>
+                  <a:srgbClr val="1B1F24"/>
+                </a:solidFill>
+                <a:latin typeface="Inter" pitchFamily="34" charset="0"/>
+                <a:ea typeface="Inter" pitchFamily="34" charset="-122"/>
+                <a:cs typeface="Inter" pitchFamily="34" charset="-120"/>
+              </a:rPr>
+              <a:t>"Which sentence gives evidence for the claim?" Distractor C restates the claim, louder.
+</a:t>
+            </a:r>
+            <a:pPr indent="0" marL="0">
+              <a:lnSpc>
+                <a:spcPct val="120000"/>
+              </a:lnSpc>
+              <a:buNone/>
+            </a:pPr>
+            <a:r>
+              <a:rPr lang="en-US" sz="1600" i="1" dirty="0">
+                <a:solidFill>
+                  <a:srgbClr val="5B6B7A"/>
+                </a:solidFill>
+                <a:latin typeface="Inter" pitchFamily="34" charset="0"/>
+                <a:ea typeface="Inter" pitchFamily="34" charset="-122"/>
+                <a:cs typeface="Inter" pitchFamily="34" charset="-120"/>
+              </a:rPr>
+              <a:t>That distractor finds exactly who holds the mix-up.</a:t>
+            </a:r>
+            <a:endParaRPr lang="en-US" sz="1600" dirty="0"/>
+          </a:p>
+        </p:txBody>
+      </p:sp>
+      <p:sp>
+        <p:nvSpPr>
+          <p:cNvPr id="18" name="Shape 15"/>
+          <p:cNvSpPr/>
+          <p:nvPr/>
+        </p:nvSpPr>
+        <p:spPr>
+          <a:xfrm>
+            <a:off x="640080" y="5257800"/>
+            <a:ext cx="10972800" cy="777240"/>
+          </a:xfrm>
+          <a:prstGeom prst="roundRect">
+            <a:avLst>
+              <a:gd name="adj" fmla="val 10588"/>
+            </a:avLst>
+          </a:prstGeom>
+          <a:solidFill>
+            <a:srgbClr val="EAF5F3"/>
+          </a:solidFill>
+          <a:ln w="12700">
+            <a:solidFill>
+              <a:srgbClr val="EAF5F3"/>
+            </a:solidFill>
+            <a:prstDash val="solid"/>
+          </a:ln>
+        </p:spPr>
+      </p:sp>
+      <p:sp>
+        <p:nvSpPr>
+          <p:cNvPr id="19" name="Text 16"/>
+          <p:cNvSpPr/>
+          <p:nvPr/>
+        </p:nvSpPr>
+        <p:spPr>
+          <a:xfrm>
+            <a:off x="960120" y="5257800"/>
+            <a:ext cx="10332720" cy="777240"/>
+          </a:xfrm>
+          <a:prstGeom prst="rect">
+            <a:avLst/>
+          </a:prstGeom>
+          <a:noFill/>
+          <a:ln/>
+        </p:spPr>
+        <p:txBody>
+          <a:bodyPr wrap="square" lIns="0" tIns="0" rIns="0" bIns="0" rtlCol="0" anchor="ctr"/>
+          <a:lstStyle/>
+          <a:p>
+            <a:pPr indent="0" marL="0">
+              <a:buNone/>
+            </a:pPr>
+            <a:r>
+              <a:rPr lang="en-US" sz="2000" b="1" dirty="0">
+                <a:solidFill>
+                  <a:srgbClr val="13293D"/>
+                </a:solidFill>
+                <a:latin typeface="Inter" pitchFamily="34" charset="0"/>
+                <a:ea typeface="Inter" pitchFamily="34" charset="-122"/>
+                <a:cs typeface="Inter" pitchFamily="34" charset="-120"/>
+              </a:rPr>
               <a:t>The misconception is the one ingredient only you can supply.</a:t>
             </a:r>
-            <a:endParaRPr lang="en-US" sz="2400" dirty="0"/>
+            <a:endParaRPr lang="en-US" sz="2000" dirty="0"/>
           </a:p>
         </p:txBody>
       </p:sp>
@@ -12344,7 +12542,7 @@
                 <a:ea typeface="Inter" pitchFamily="34" charset="-122"/>
                 <a:cs typeface="Inter" pitchFamily="34" charset="-120"/>
               </a:rPr>
-              <a:t>Her vetting rep: found the weak question, caught and cut it.</a:t>
+              <a:t>Her essay bank, vetted: question 7 had two fair answers. Caught and cut.</a:t>
             </a:r>
             <a:endParaRPr lang="en-US" sz="1000" dirty="0"/>
           </a:p>
@@ -12398,23 +12596,23 @@
         <p:spPr>
           <a:xfrm>
             <a:off x="548640" y="384048"/>
-            <a:ext cx="11091672" cy="777240"/>
-          </a:xfrm>
-          <a:prstGeom prst="rect">
-            <a:avLst/>
-          </a:prstGeom>
-          <a:noFill/>
-          <a:ln/>
-        </p:spPr>
-        <p:txBody>
-          <a:bodyPr wrap="square" lIns="0" tIns="0" rIns="0" bIns="0" rtlCol="0" anchor="ctr"/>
-          <a:lstStyle/>
-          <a:p>
-            <a:pPr indent="0" marL="0">
-              <a:buNone/>
-            </a:pPr>
-            <a:r>
-              <a:rPr lang="en-US" sz="3200" b="1" dirty="0">
+            <a:ext cx="7955280" cy="777240"/>
+          </a:xfrm>
+          <a:prstGeom prst="rect">
+            <a:avLst/>
+          </a:prstGeom>
+          <a:noFill/>
+          <a:ln/>
+        </p:spPr>
+        <p:txBody>
+          <a:bodyPr wrap="square" lIns="0" tIns="0" rIns="0" bIns="0" rtlCol="0" anchor="ctr"/>
+          <a:lstStyle/>
+          <a:p>
+            <a:pPr indent="0" marL="0">
+              <a:buNone/>
+            </a:pPr>
+            <a:r>
+              <a:rPr lang="en-US" sz="2800" b="1" dirty="0">
                 <a:solidFill>
                   <a:srgbClr val="13293D"/>
                 </a:solidFill>
@@ -12424,32 +12622,138 @@
               </a:rPr>
               <a:t>The vetting rep: find the weak one</a:t>
             </a:r>
-            <a:endParaRPr lang="en-US" sz="3200" dirty="0"/>
-          </a:p>
-        </p:txBody>
-      </p:sp>
-      <p:sp>
-        <p:nvSpPr>
-          <p:cNvPr id="14" name="Shape 11"/>
-          <p:cNvSpPr/>
-          <p:nvPr/>
-        </p:nvSpPr>
-        <p:spPr>
-          <a:xfrm>
-            <a:off x="640080" y="1508760"/>
-            <a:ext cx="10972800" cy="731520"/>
+            <a:endParaRPr lang="en-US" sz="2800" dirty="0"/>
+          </a:p>
+        </p:txBody>
+      </p:sp>
+      <p:sp>
+        <p:nvSpPr>
+          <p:cNvPr id="14" name="Text 11"/>
+          <p:cNvSpPr/>
+          <p:nvPr/>
+        </p:nvSpPr>
+        <p:spPr>
+          <a:xfrm>
+            <a:off x="640080" y="1554480"/>
+            <a:ext cx="5394960" cy="3566160"/>
+          </a:xfrm>
+          <a:prstGeom prst="rect">
+            <a:avLst/>
+          </a:prstGeom>
+          <a:noFill/>
+          <a:ln/>
+        </p:spPr>
+        <p:txBody>
+          <a:bodyPr wrap="square" rtlCol="0" anchor="t"/>
+          <a:lstStyle/>
+          <a:p>
+            <a:pPr marL="342900" indent="-342900">
+              <a:spcAft>
+                <a:spcPts val="1000"/>
+              </a:spcAft>
+              <a:buSzPct val="100000"/>
+              <a:buChar char="•"/>
+            </a:pPr>
+            <a:r>
+              <a:rPr lang="en-US" sz="1600" dirty="0">
+                <a:solidFill>
+                  <a:srgbClr val="1B1F24"/>
+                </a:solidFill>
+                <a:latin typeface="Inter" pitchFamily="34" charset="0"/>
+                <a:ea typeface="Inter" pitchFamily="34" charset="-122"/>
+                <a:cs typeface="Inter" pitchFamily="34" charset="-120"/>
+              </a:rPr>
+              <a:t>Answer key checked against your own professional knowledge</a:t>
+            </a:r>
+            <a:endParaRPr lang="en-US" sz="1600" dirty="0"/>
+          </a:p>
+          <a:p>
+            <a:pPr marL="342900" indent="-342900">
+              <a:spcAft>
+                <a:spcPts val="1000"/>
+              </a:spcAft>
+              <a:buSzPct val="100000"/>
+              <a:buChar char="•"/>
+            </a:pPr>
+            <a:r>
+              <a:rPr lang="en-US" sz="1600" dirty="0">
+                <a:solidFill>
+                  <a:srgbClr val="1B1F24"/>
+                </a:solidFill>
+                <a:latin typeface="Inter" pitchFamily="34" charset="0"/>
+                <a:ea typeface="Inter" pitchFamily="34" charset="-122"/>
+                <a:cs typeface="Inter" pitchFamily="34" charset="-120"/>
+              </a:rPr>
+              <a:t>Every distractor checked for accidental truth</a:t>
+            </a:r>
+            <a:endParaRPr lang="en-US" sz="1600" dirty="0"/>
+          </a:p>
+          <a:p>
+            <a:pPr marL="342900" indent="-342900">
+              <a:spcAft>
+                <a:spcPts val="1000"/>
+              </a:spcAft>
+              <a:buSzPct val="100000"/>
+              <a:buChar char="•"/>
+            </a:pPr>
+            <a:r>
+              <a:rPr lang="en-US" sz="1600" dirty="0">
+                <a:solidFill>
+                  <a:srgbClr val="1B1F24"/>
+                </a:solidFill>
+                <a:latin typeface="Inter" pitchFamily="34" charset="0"/>
+                <a:ea typeface="Inter" pitchFamily="34" charset="-122"/>
+                <a:cs typeface="Inter" pitchFamily="34" charset="-120"/>
+              </a:rPr>
+              <a:t>Reading level right? Exactly one fair answer per question?</a:t>
+            </a:r>
+            <a:endParaRPr lang="en-US" sz="1600" dirty="0"/>
+          </a:p>
+          <a:p>
+            <a:pPr marL="342900" indent="-342900">
+              <a:spcAft>
+                <a:spcPts val="1000"/>
+              </a:spcAft>
+              <a:buSzPct val="100000"/>
+              <a:buChar char="•"/>
+            </a:pPr>
+            <a:r>
+              <a:rPr lang="en-US" sz="1600" dirty="0">
+                <a:solidFill>
+                  <a:srgbClr val="1B1F24"/>
+                </a:solidFill>
+                <a:latin typeface="Inter" pitchFamily="34" charset="0"/>
+                <a:ea typeface="Inter" pitchFamily="34" charset="-122"/>
+                <a:cs typeface="Inter" pitchFamily="34" charset="-120"/>
+              </a:rPr>
+              <a:t>Weakest question: fix it by hand, or delete it and write its replacement yourself</a:t>
+            </a:r>
+            <a:endParaRPr lang="en-US" sz="1600" dirty="0"/>
+          </a:p>
+        </p:txBody>
+      </p:sp>
+      <p:sp>
+        <p:nvSpPr>
+          <p:cNvPr id="15" name="Shape 12"/>
+          <p:cNvSpPr/>
+          <p:nvPr/>
+        </p:nvSpPr>
+        <p:spPr>
+          <a:xfrm>
+            <a:off x="6263640" y="1554480"/>
+            <a:ext cx="5394960" cy="3566160"/>
           </a:xfrm>
           <a:prstGeom prst="roundRect">
             <a:avLst>
-              <a:gd name="adj" fmla="val 11250"/>
+              <a:gd name="adj" fmla="val 2308"/>
             </a:avLst>
           </a:prstGeom>
           <a:solidFill>
-            <a:srgbClr val="F7F5F0"/>
+            <a:srgbClr val="EAF5F3"/>
           </a:solidFill>
           <a:ln w="12700">
             <a:solidFill>
-              <a:srgbClr val="F7F5F0"/>
+              <a:srgbClr val="EAF5F3"/>
             </a:solidFill>
             <a:prstDash val="solid"/>
           </a:ln>
@@ -12457,30 +12761,89 @@
       </p:sp>
       <p:sp>
         <p:nvSpPr>
-          <p:cNvPr id="15" name="Text 12"/>
-          <p:cNvSpPr/>
-          <p:nvPr/>
-        </p:nvSpPr>
-        <p:spPr>
-          <a:xfrm>
-            <a:off x="960120" y="1563624"/>
-            <a:ext cx="10332720" cy="621792"/>
-          </a:xfrm>
-          <a:prstGeom prst="rect">
-            <a:avLst/>
-          </a:prstGeom>
-          <a:noFill/>
-          <a:ln/>
-        </p:spPr>
-        <p:txBody>
-          <a:bodyPr wrap="square" lIns="0" tIns="0" rIns="0" bIns="0" rtlCol="0" anchor="ctr"/>
-          <a:lstStyle/>
-          <a:p>
-            <a:pPr indent="0" marL="0">
-              <a:buNone/>
-            </a:pPr>
-            <a:r>
-              <a:rPr lang="en-US" sz="1800" dirty="0">
+          <p:cNvPr id="16" name="Text 13"/>
+          <p:cNvSpPr/>
+          <p:nvPr/>
+        </p:nvSpPr>
+        <p:spPr>
+          <a:xfrm>
+            <a:off x="6537960" y="1737360"/>
+            <a:ext cx="4937760" cy="292608"/>
+          </a:xfrm>
+          <a:prstGeom prst="rect">
+            <a:avLst/>
+          </a:prstGeom>
+          <a:noFill/>
+          <a:ln/>
+        </p:spPr>
+        <p:txBody>
+          <a:bodyPr wrap="square" lIns="0" tIns="0" rIns="0" bIns="0" rtlCol="0" anchor="ctr"/>
+          <a:lstStyle/>
+          <a:p>
+            <a:pPr indent="0" marL="0">
+              <a:buNone/>
+            </a:pPr>
+            <a:r>
+              <a:rPr lang="en-US" sz="1250" b="1" spc="150" kern="0" dirty="0">
+                <a:solidFill>
+                  <a:srgbClr val="2A9D8F"/>
+                </a:solidFill>
+                <a:latin typeface="Inter" pitchFamily="34" charset="0"/>
+                <a:ea typeface="Inter" pitchFamily="34" charset="-122"/>
+                <a:cs typeface="Inter" pitchFamily="34" charset="-120"/>
+              </a:rPr>
+              <a:t>MS. RIVERA'S ESSAY · STEP 2 · HER CATCH</a:t>
+            </a:r>
+            <a:endParaRPr lang="en-US" sz="1250" dirty="0"/>
+          </a:p>
+        </p:txBody>
+      </p:sp>
+      <p:sp>
+        <p:nvSpPr>
+          <p:cNvPr id="17" name="Text 14"/>
+          <p:cNvSpPr/>
+          <p:nvPr/>
+        </p:nvSpPr>
+        <p:spPr>
+          <a:xfrm>
+            <a:off x="6537960" y="2148840"/>
+            <a:ext cx="4892040" cy="2834640"/>
+          </a:xfrm>
+          <a:prstGeom prst="rect">
+            <a:avLst/>
+          </a:prstGeom>
+          <a:noFill/>
+          <a:ln/>
+        </p:spPr>
+        <p:txBody>
+          <a:bodyPr wrap="square" lIns="0" tIns="0" rIns="0" bIns="0" rtlCol="0" anchor="t"/>
+          <a:lstStyle/>
+          <a:p>
+            <a:pPr indent="0" marL="0">
+              <a:lnSpc>
+                <a:spcPct val="125000"/>
+              </a:lnSpc>
+              <a:buNone/>
+            </a:pPr>
+            <a:r>
+              <a:rPr lang="en-US" sz="1700" b="1" dirty="0">
+                <a:solidFill>
+                  <a:srgbClr val="13293D"/>
+                </a:solidFill>
+                <a:latin typeface="Inter" pitchFamily="34" charset="0"/>
+                <a:ea typeface="Inter" pitchFamily="34" charset="-122"/>
+                <a:cs typeface="Inter" pitchFamily="34" charset="-120"/>
+              </a:rPr>
+              <a:t>The catch: </a:t>
+            </a:r>
+            <a:pPr indent="0" marL="0">
+              <a:lnSpc>
+                <a:spcPct val="125000"/>
+              </a:lnSpc>
+              <a:buNone/>
+            </a:pPr>
+            <a:r>
+              <a:rPr lang="en-US" sz="1700" dirty="0">
                 <a:solidFill>
                   <a:srgbClr val="1B1F24"/>
                 </a:solidFill>
@@ -12488,65 +12851,34 @@
                 <a:ea typeface="Inter" pitchFamily="34" charset="-122"/>
                 <a:cs typeface="Inter" pitchFamily="34" charset="-120"/>
               </a:rPr>
-              <a:t>Answer key checked against your own professional knowledge</a:t>
-            </a:r>
-            <a:endParaRPr lang="en-US" sz="1800" dirty="0"/>
-          </a:p>
-        </p:txBody>
-      </p:sp>
-      <p:sp>
-        <p:nvSpPr>
-          <p:cNvPr id="16" name="Shape 13"/>
-          <p:cNvSpPr/>
-          <p:nvPr/>
-        </p:nvSpPr>
-        <p:spPr>
-          <a:xfrm>
-            <a:off x="640080" y="2377440"/>
-            <a:ext cx="10972800" cy="731520"/>
-          </a:xfrm>
-          <a:prstGeom prst="roundRect">
-            <a:avLst>
-              <a:gd name="adj" fmla="val 11250"/>
-            </a:avLst>
-          </a:prstGeom>
-          <a:solidFill>
-            <a:srgbClr val="F7F5F0"/>
-          </a:solidFill>
-          <a:ln w="12700">
-            <a:solidFill>
-              <a:srgbClr val="F7F5F0"/>
-            </a:solidFill>
-            <a:prstDash val="solid"/>
-          </a:ln>
-        </p:spPr>
-      </p:sp>
-      <p:sp>
-        <p:nvSpPr>
-          <p:cNvPr id="17" name="Text 14"/>
-          <p:cNvSpPr/>
-          <p:nvPr/>
-        </p:nvSpPr>
-        <p:spPr>
-          <a:xfrm>
-            <a:off x="960120" y="2432304"/>
-            <a:ext cx="10332720" cy="621792"/>
-          </a:xfrm>
-          <a:prstGeom prst="rect">
-            <a:avLst/>
-          </a:prstGeom>
-          <a:noFill/>
-          <a:ln/>
-        </p:spPr>
-        <p:txBody>
-          <a:bodyPr wrap="square" lIns="0" tIns="0" rIns="0" bIns="0" rtlCol="0" anchor="ctr"/>
-          <a:lstStyle/>
-          <a:p>
-            <a:pPr indent="0" marL="0">
-              <a:buNone/>
-            </a:pPr>
-            <a:r>
-              <a:rPr lang="en-US" sz="1800" dirty="0">
+              <a:t>question 7's "wrong" answer was defensible too. Two fair answers, one question.
+</a:t>
+            </a:r>
+            <a:pPr indent="0" marL="0">
+              <a:lnSpc>
+                <a:spcPct val="125000"/>
+              </a:lnSpc>
+              <a:buNone/>
+            </a:pPr>
+            <a:r>
+              <a:rPr lang="en-US" sz="1700" b="1" dirty="0">
+                <a:solidFill>
+                  <a:srgbClr val="13293D"/>
+                </a:solidFill>
+                <a:latin typeface="Inter" pitchFamily="34" charset="0"/>
+                <a:ea typeface="Inter" pitchFamily="34" charset="-122"/>
+                <a:cs typeface="Inter" pitchFamily="34" charset="-120"/>
+              </a:rPr>
+              <a:t>The fix: </a:t>
+            </a:r>
+            <a:pPr indent="0" marL="0">
+              <a:lnSpc>
+                <a:spcPct val="125000"/>
+              </a:lnSpc>
+              <a:buNone/>
+            </a:pPr>
+            <a:r>
+              <a:rPr lang="en-US" sz="1700" dirty="0">
                 <a:solidFill>
                   <a:srgbClr val="1B1F24"/>
                 </a:solidFill>
@@ -12554,153 +12886,39 @@
                 <a:ea typeface="Inter" pitchFamily="34" charset="-122"/>
                 <a:cs typeface="Inter" pitchFamily="34" charset="-120"/>
               </a:rPr>
-              <a:t>Every distractor checked for accidental truth</a:t>
-            </a:r>
-            <a:endParaRPr lang="en-US" sz="1800" dirty="0"/>
-          </a:p>
-        </p:txBody>
-      </p:sp>
-      <p:sp>
-        <p:nvSpPr>
-          <p:cNvPr id="18" name="Shape 15"/>
-          <p:cNvSpPr/>
-          <p:nvPr/>
-        </p:nvSpPr>
-        <p:spPr>
-          <a:xfrm>
-            <a:off x="640080" y="3246120"/>
-            <a:ext cx="10972800" cy="731520"/>
-          </a:xfrm>
-          <a:prstGeom prst="roundRect">
-            <a:avLst>
-              <a:gd name="adj" fmla="val 11250"/>
-            </a:avLst>
-          </a:prstGeom>
-          <a:solidFill>
-            <a:srgbClr val="F7F5F0"/>
-          </a:solidFill>
-          <a:ln w="12700">
-            <a:solidFill>
-              <a:srgbClr val="F7F5F0"/>
-            </a:solidFill>
-            <a:prstDash val="solid"/>
-          </a:ln>
-        </p:spPr>
-      </p:sp>
-      <p:sp>
-        <p:nvSpPr>
-          <p:cNvPr id="19" name="Text 16"/>
-          <p:cNvSpPr/>
-          <p:nvPr/>
-        </p:nvSpPr>
-        <p:spPr>
-          <a:xfrm>
-            <a:off x="960120" y="3300984"/>
-            <a:ext cx="10332720" cy="621792"/>
-          </a:xfrm>
-          <a:prstGeom prst="rect">
-            <a:avLst/>
-          </a:prstGeom>
-          <a:noFill/>
-          <a:ln/>
-        </p:spPr>
-        <p:txBody>
-          <a:bodyPr wrap="square" lIns="0" tIns="0" rIns="0" bIns="0" rtlCol="0" anchor="ctr"/>
-          <a:lstStyle/>
-          <a:p>
-            <a:pPr indent="0" marL="0">
-              <a:buNone/>
-            </a:pPr>
-            <a:r>
-              <a:rPr lang="en-US" sz="1800" dirty="0">
-                <a:solidFill>
-                  <a:srgbClr val="1B1F24"/>
-                </a:solidFill>
-                <a:latin typeface="Inter" pitchFamily="34" charset="0"/>
-                <a:ea typeface="Inter" pitchFamily="34" charset="-122"/>
-                <a:cs typeface="Inter" pitchFamily="34" charset="-120"/>
-              </a:rPr>
-              <a:t>Reading level right? Exactly one fair answer per question?</a:t>
-            </a:r>
-            <a:endParaRPr lang="en-US" sz="1800" dirty="0"/>
-          </a:p>
-        </p:txBody>
-      </p:sp>
-      <p:sp>
-        <p:nvSpPr>
-          <p:cNvPr id="20" name="Shape 17"/>
-          <p:cNvSpPr/>
-          <p:nvPr/>
-        </p:nvSpPr>
-        <p:spPr>
-          <a:xfrm>
-            <a:off x="640080" y="4114800"/>
-            <a:ext cx="10972800" cy="731520"/>
-          </a:xfrm>
-          <a:prstGeom prst="roundRect">
-            <a:avLst>
-              <a:gd name="adj" fmla="val 11250"/>
-            </a:avLst>
-          </a:prstGeom>
-          <a:solidFill>
-            <a:srgbClr val="F7F5F0"/>
-          </a:solidFill>
-          <a:ln w="12700">
-            <a:solidFill>
-              <a:srgbClr val="F7F5F0"/>
-            </a:solidFill>
-            <a:prstDash val="solid"/>
-          </a:ln>
-        </p:spPr>
-      </p:sp>
-      <p:sp>
-        <p:nvSpPr>
-          <p:cNvPr id="21" name="Text 18"/>
-          <p:cNvSpPr/>
-          <p:nvPr/>
-        </p:nvSpPr>
-        <p:spPr>
-          <a:xfrm>
-            <a:off x="960120" y="4169664"/>
-            <a:ext cx="10332720" cy="621792"/>
-          </a:xfrm>
-          <a:prstGeom prst="rect">
-            <a:avLst/>
-          </a:prstGeom>
-          <a:noFill/>
-          <a:ln/>
-        </p:spPr>
-        <p:txBody>
-          <a:bodyPr wrap="square" lIns="0" tIns="0" rIns="0" bIns="0" rtlCol="0" anchor="ctr"/>
-          <a:lstStyle/>
-          <a:p>
-            <a:pPr indent="0" marL="0">
-              <a:buNone/>
-            </a:pPr>
-            <a:r>
-              <a:rPr lang="en-US" sz="1800" dirty="0">
-                <a:solidFill>
-                  <a:srgbClr val="1B1F24"/>
-                </a:solidFill>
-                <a:latin typeface="Inter" pitchFamily="34" charset="0"/>
-                <a:ea typeface="Inter" pitchFamily="34" charset="-122"/>
-                <a:cs typeface="Inter" pitchFamily="34" charset="-120"/>
-              </a:rPr>
-              <a:t>Weakest question: fix it by hand, or delete it and write its replacement yourself</a:t>
-            </a:r>
-            <a:endParaRPr lang="en-US" sz="1800" dirty="0"/>
-          </a:p>
-        </p:txBody>
-      </p:sp>
-      <p:sp>
-        <p:nvSpPr>
-          <p:cNvPr id="22" name="Text 19"/>
-          <p:cNvSpPr/>
-          <p:nvPr/>
-        </p:nvSpPr>
-        <p:spPr>
-          <a:xfrm>
-            <a:off x="640080" y="5212080"/>
+              <a:t>she cut it and wrote the replacement herself.
+</a:t>
+            </a:r>
+            <a:pPr indent="0" marL="0">
+              <a:lnSpc>
+                <a:spcPct val="125000"/>
+              </a:lnSpc>
+              <a:buNone/>
+            </a:pPr>
+            <a:r>
+              <a:rPr lang="en-US" sz="1700" b="1" i="1" dirty="0">
+                <a:solidFill>
+                  <a:srgbClr val="13293D"/>
+                </a:solidFill>
+                <a:latin typeface="Inter" pitchFamily="34" charset="0"/>
+                <a:ea typeface="Inter" pitchFamily="34" charset="-122"/>
+                <a:cs typeface="Inter" pitchFamily="34" charset="-120"/>
+              </a:rPr>
+              <a:t>"Got one."</a:t>
+            </a:r>
+            <a:endParaRPr lang="en-US" sz="1700" dirty="0"/>
+          </a:p>
+        </p:txBody>
+      </p:sp>
+      <p:sp>
+        <p:nvSpPr>
+          <p:cNvPr id="18" name="Text 15"/>
+          <p:cNvSpPr/>
+          <p:nvPr/>
+        </p:nvSpPr>
+        <p:spPr>
+          <a:xfrm>
+            <a:off x="640080" y="5349240"/>
             <a:ext cx="10972800" cy="457200"/>
           </a:xfrm>
           <a:prstGeom prst="rect">
@@ -13080,7 +13298,7 @@
                 <a:ea typeface="Inter" pitchFamily="34" charset="-122"/>
                 <a:cs typeface="Inter" pitchFamily="34" charset="-120"/>
               </a:rPr>
-              <a:t>Her starters: three patterns she writes every stack, drafted once.</a:t>
+              <a:t>Her essay starters, on screen: three patterns from her essay stacks, drafted once.</a:t>
             </a:r>
             <a:endParaRPr lang="en-US" sz="1000" dirty="0"/>
           </a:p>
@@ -13134,7 +13352,7 @@
         <p:spPr>
           <a:xfrm>
             <a:off x="548640" y="384048"/>
-            <a:ext cx="11091672" cy="777240"/>
+            <a:ext cx="7955280" cy="777240"/>
           </a:xfrm>
           <a:prstGeom prst="rect">
             <a:avLst/>
@@ -13172,8 +13390,8 @@
         </p:nvSpPr>
         <p:spPr>
           <a:xfrm>
-            <a:off x="640080" y="1463040"/>
-            <a:ext cx="10908792" cy="2286000"/>
+            <a:off x="640080" y="1554480"/>
+            <a:ext cx="5394960" cy="3566160"/>
           </a:xfrm>
           <a:prstGeom prst="rect">
             <a:avLst/>
@@ -13193,7 +13411,7 @@
               <a:buChar char="•"/>
             </a:pPr>
             <a:r>
-              <a:rPr lang="en-US" sz="2100" dirty="0">
+              <a:rPr lang="en-US" sz="1600" dirty="0">
                 <a:solidFill>
                   <a:srgbClr val="1B1F24"/>
                 </a:solidFill>
@@ -13203,7 +13421,7 @@
               </a:rPr>
               <a:t>Name your three most common student patterns for this kind of work</a:t>
             </a:r>
-            <a:endParaRPr lang="en-US" sz="2100" dirty="0"/>
+            <a:endParaRPr lang="en-US" sz="1600" dirty="0"/>
           </a:p>
           <a:p>
             <a:pPr marL="342900" indent="-342900">
@@ -13214,7 +13432,7 @@
               <a:buChar char="•"/>
             </a:pPr>
             <a:r>
-              <a:rPr lang="en-US" sz="2100" dirty="0">
+              <a:rPr lang="en-US" sz="1600" dirty="0">
                 <a:solidFill>
                   <a:srgbClr val="1B1F24"/>
                 </a:solidFill>
@@ -13224,7 +13442,7 @@
               </a:rPr>
               <a:t>Run the pattern prompt: strength, pattern, next step, in plain student language</a:t>
             </a:r>
-            <a:endParaRPr lang="en-US" sz="2100" dirty="0"/>
+            <a:endParaRPr lang="en-US" sz="1600" dirty="0"/>
           </a:p>
           <a:p>
             <a:pPr marL="342900" indent="-342900">
@@ -13235,7 +13453,7 @@
               <a:buChar char="•"/>
             </a:pPr>
             <a:r>
-              <a:rPr lang="en-US" sz="2100" dirty="0">
+              <a:rPr lang="en-US" sz="1600" dirty="0">
                 <a:solidFill>
                   <a:srgbClr val="1B1F24"/>
                 </a:solidFill>
@@ -13245,7 +13463,7 @@
               </a:rPr>
               <a:t>Save all three where you grade; paste your best one into the staff doc’s Assessment section</a:t>
             </a:r>
-            <a:endParaRPr lang="en-US" sz="2100" dirty="0"/>
+            <a:endParaRPr lang="en-US" sz="1600" dirty="0"/>
           </a:p>
         </p:txBody>
       </p:sp>
@@ -13257,12 +13475,12 @@
         </p:nvSpPr>
         <p:spPr>
           <a:xfrm>
-            <a:off x="640080" y="3931920"/>
-            <a:ext cx="10972800" cy="1737360"/>
+            <a:off x="6263640" y="1554480"/>
+            <a:ext cx="5394960" cy="3566160"/>
           </a:xfrm>
           <a:prstGeom prst="roundRect">
             <a:avLst>
-              <a:gd name="adj" fmla="val 4737"/>
+              <a:gd name="adj" fmla="val 2308"/>
             </a:avLst>
           </a:prstGeom>
           <a:solidFill>
@@ -13284,24 +13502,66 @@
         </p:nvSpPr>
         <p:spPr>
           <a:xfrm>
-            <a:off x="960120" y="4160520"/>
-            <a:ext cx="10332720" cy="1280160"/>
-          </a:xfrm>
-          <a:prstGeom prst="rect">
-            <a:avLst/>
-          </a:prstGeom>
-          <a:noFill/>
-          <a:ln/>
-        </p:spPr>
-        <p:txBody>
-          <a:bodyPr wrap="square" lIns="0" tIns="0" rIns="0" bIns="0" rtlCol="0" anchor="ctr"/>
-          <a:lstStyle/>
-          <a:p>
-            <a:pPr indent="0" marL="0">
-              <a:buNone/>
-            </a:pPr>
-            <a:r>
-              <a:rPr lang="en-US" sz="2100" b="1" dirty="0">
+            <a:off x="6537960" y="1737360"/>
+            <a:ext cx="4937760" cy="292608"/>
+          </a:xfrm>
+          <a:prstGeom prst="rect">
+            <a:avLst/>
+          </a:prstGeom>
+          <a:noFill/>
+          <a:ln/>
+        </p:spPr>
+        <p:txBody>
+          <a:bodyPr wrap="square" lIns="0" tIns="0" rIns="0" bIns="0" rtlCol="0" anchor="ctr"/>
+          <a:lstStyle/>
+          <a:p>
+            <a:pPr indent="0" marL="0">
+              <a:buNone/>
+            </a:pPr>
+            <a:r>
+              <a:rPr lang="en-US" sz="1250" b="1" spc="150" kern="0" dirty="0">
+                <a:solidFill>
+                  <a:srgbClr val="2A9D8F"/>
+                </a:solidFill>
+                <a:latin typeface="Inter" pitchFamily="34" charset="0"/>
+                <a:ea typeface="Inter" pitchFamily="34" charset="-122"/>
+                <a:cs typeface="Inter" pitchFamily="34" charset="-120"/>
+              </a:rPr>
+              <a:t>MS. RIVERA'S ESSAY · STEP 3 · HER STARTERS</a:t>
+            </a:r>
+            <a:endParaRPr lang="en-US" sz="1250" dirty="0"/>
+          </a:p>
+        </p:txBody>
+      </p:sp>
+      <p:sp>
+        <p:nvSpPr>
+          <p:cNvPr id="17" name="Text 14"/>
+          <p:cNvSpPr/>
+          <p:nvPr/>
+        </p:nvSpPr>
+        <p:spPr>
+          <a:xfrm>
+            <a:off x="6537960" y="2148840"/>
+            <a:ext cx="4892040" cy="2834640"/>
+          </a:xfrm>
+          <a:prstGeom prst="rect">
+            <a:avLst/>
+          </a:prstGeom>
+          <a:noFill/>
+          <a:ln/>
+        </p:spPr>
+        <p:txBody>
+          <a:bodyPr wrap="square" lIns="0" tIns="0" rIns="0" bIns="0" rtlCol="0" anchor="t"/>
+          <a:lstStyle/>
+          <a:p>
+            <a:pPr indent="0" marL="0">
+              <a:lnSpc>
+                <a:spcPct val="120000"/>
+              </a:lnSpc>
+              <a:buNone/>
+            </a:pPr>
+            <a:r>
+              <a:rPr lang="en-US" sz="1550" b="1" dirty="0">
                 <a:solidFill>
                   <a:srgbClr val="13293D"/>
                 </a:solidFill>
@@ -13309,9 +13569,128 @@
                 <a:ea typeface="Inter" pitchFamily="34" charset="-122"/>
                 <a:cs typeface="Inter" pitchFamily="34" charset="-120"/>
               </a:rPr>
+              <a:t>Her pattern: </a:t>
+            </a:r>
+            <a:pPr indent="0" marL="0">
+              <a:lnSpc>
+                <a:spcPct val="120000"/>
+              </a:lnSpc>
+              <a:buNone/>
+            </a:pPr>
+            <a:r>
+              <a:rPr lang="en-US" sz="1550" dirty="0">
+                <a:solidFill>
+                  <a:srgbClr val="1B1F24"/>
+                </a:solidFill>
+                <a:latin typeface="Inter" pitchFamily="34" charset="0"/>
+                <a:ea typeface="Inter" pitchFamily="34" charset="-122"/>
+                <a:cs typeface="Inter" pitchFamily="34" charset="-120"/>
+              </a:rPr>
+              <a:t>claims with no evidence.
+</a:t>
+            </a:r>
+            <a:pPr indent="0" marL="0">
+              <a:lnSpc>
+                <a:spcPct val="120000"/>
+              </a:lnSpc>
+              <a:buNone/>
+            </a:pPr>
+            <a:r>
+              <a:rPr lang="en-US" sz="1550" i="1" dirty="0">
+                <a:solidFill>
+                  <a:srgbClr val="1B1F24"/>
+                </a:solidFill>
+                <a:latin typeface="Inter" pitchFamily="34" charset="0"/>
+                <a:ea typeface="Inter" pitchFamily="34" charset="-122"/>
+                <a:cs typeface="Inter" pitchFamily="34" charset="-120"/>
+              </a:rPr>
+              <a:t>"Your claim is clear and confident. Right now the essay repeats it instead of backing it up. Pick your strongest fact and add one sentence on why it proves your point."
+</a:t>
+            </a:r>
+            <a:pPr indent="0" marL="0">
+              <a:lnSpc>
+                <a:spcPct val="120000"/>
+              </a:lnSpc>
+              <a:buNone/>
+            </a:pPr>
+            <a:r>
+              <a:rPr lang="en-US" sz="1550" i="1" dirty="0">
+                <a:solidFill>
+                  <a:srgbClr val="5B6B7A"/>
+                </a:solidFill>
+                <a:latin typeface="Inter" pitchFamily="34" charset="0"/>
+                <a:ea typeface="Inter" pitchFamily="34" charset="-122"/>
+                <a:cs typeface="Inter" pitchFamily="34" charset="-120"/>
+              </a:rPr>
+              <a:t>Personalized before any student sees it.</a:t>
+            </a:r>
+            <a:endParaRPr lang="en-US" sz="1550" dirty="0"/>
+          </a:p>
+        </p:txBody>
+      </p:sp>
+      <p:sp>
+        <p:nvSpPr>
+          <p:cNvPr id="18" name="Shape 15"/>
+          <p:cNvSpPr/>
+          <p:nvPr/>
+        </p:nvSpPr>
+        <p:spPr>
+          <a:xfrm>
+            <a:off x="640080" y="5257800"/>
+            <a:ext cx="10972800" cy="777240"/>
+          </a:xfrm>
+          <a:prstGeom prst="roundRect">
+            <a:avLst>
+              <a:gd name="adj" fmla="val 10588"/>
+            </a:avLst>
+          </a:prstGeom>
+          <a:solidFill>
+            <a:srgbClr val="EAF5F3"/>
+          </a:solidFill>
+          <a:ln w="12700">
+            <a:solidFill>
+              <a:srgbClr val="EAF5F3"/>
+            </a:solidFill>
+            <a:prstDash val="solid"/>
+          </a:ln>
+        </p:spPr>
+      </p:sp>
+      <p:sp>
+        <p:nvSpPr>
+          <p:cNvPr id="19" name="Text 16"/>
+          <p:cNvSpPr/>
+          <p:nvPr/>
+        </p:nvSpPr>
+        <p:spPr>
+          <a:xfrm>
+            <a:off x="960120" y="5257800"/>
+            <a:ext cx="10332720" cy="777240"/>
+          </a:xfrm>
+          <a:prstGeom prst="rect">
+            <a:avLst/>
+          </a:prstGeom>
+          <a:noFill/>
+          <a:ln/>
+        </p:spPr>
+        <p:txBody>
+          <a:bodyPr wrap="square" lIns="0" tIns="0" rIns="0" bIns="0" rtlCol="0" anchor="ctr"/>
+          <a:lstStyle/>
+          <a:p>
+            <a:pPr indent="0" marL="0">
+              <a:buNone/>
+            </a:pPr>
+            <a:r>
+              <a:rPr lang="en-US" sz="1800" b="1" dirty="0">
+                <a:solidFill>
+                  <a:srgbClr val="13293D"/>
+                </a:solidFill>
+                <a:latin typeface="Inter" pitchFamily="34" charset="0"/>
+                <a:ea typeface="Inter" pitchFamily="34" charset="-122"/>
+                <a:cs typeface="Inter" pitchFamily="34" charset="-120"/>
+              </a:rPr>
               <a:t>Starters, not stamps: in real grading you’ll personalize every one before it reaches a kid.</a:t>
             </a:r>
-            <a:endParaRPr lang="en-US" sz="2100" dirty="0"/>
+            <a:endParaRPr lang="en-US" sz="1800" dirty="0"/>
           </a:p>
         </p:txBody>
       </p:sp>
@@ -13664,7 +14043,7 @@
                 <a:ea typeface="Inter" pitchFamily="34" charset="-122"/>
                 <a:cs typeface="Inter" pitchFamily="34" charset="-120"/>
               </a:rPr>
-              <a:t>Her share-out: the catch story goes first.</a:t>
+              <a:t>Her share-out: the catch from her essay bank goes first.</a:t>
             </a:r>
             <a:endParaRPr lang="en-US" sz="1000" dirty="0"/>
           </a:p>
@@ -14182,7 +14561,7 @@
                 <a:ea typeface="Inter" pitchFamily="34" charset="-122"/>
                 <a:cs typeface="Inter" pitchFamily="34" charset="-120"/>
               </a:rPr>
-              <a:t>Her inventory: rubric, vetted bank, three starters, one caught question.</a:t>
+              <a:t>Her essay inventory: rubric, vetted bank, three starters, one catch.</a:t>
             </a:r>
             <a:endParaRPr lang="en-US" sz="1000" dirty="0"/>
           </a:p>

</xml_diff>